<commit_message>
Quartz sync: Sep 22, 2026, 6:56 PM
</commit_message>
<xml_diff>
--- a/content/Articles/session55tokens.pptx
+++ b/content/Articles/session55tokens.pptx
@@ -7,6 +7,12 @@
   <p:sldIdLst>
     <p:sldId id="274" r:id="rId2"/>
     <p:sldId id="280" r:id="rId3"/>
+    <p:sldId id="281" r:id="rId4"/>
+    <p:sldId id="256" r:id="rId5"/>
+    <p:sldId id="257" r:id="rId6"/>
+    <p:sldId id="258" r:id="rId7"/>
+    <p:sldId id="259" r:id="rId8"/>
+    <p:sldId id="260" r:id="rId9"/>
   </p:sldIdLst>
   <p:sldSz cx="7772400" cy="10058400"/>
   <p:notesSz cx="7315200" cy="9601200"/>
@@ -116,7 +122,7 @@
 <file path=ppt/revisionInfo.xml><?xml version="1.0" encoding="utf-8"?>
 <p1510:revInfo xmlns:a="http://schemas.openxmlformats.org/drawingml/2006/main" xmlns:r="http://schemas.openxmlformats.org/officeDocument/2006/relationships" xmlns:p1510="http://schemas.microsoft.com/office/powerpoint/2015/10/main">
   <p1510:revLst>
-    <p1510:client id="{9C220C1B-68D8-46B5-91D8-A4A4BD152C72}" v="2" dt="2026-09-22T05:37:48.916"/>
+    <p1510:client id="{9C220C1B-68D8-46B5-91D8-A4A4BD152C72}" v="5" dt="2026-09-22T22:00:00.996"/>
   </p1510:revLst>
 </p1510:revInfo>
 </file>
@@ -126,10 +132,293 @@
   <pc:docChgLst>
     <pc:chgData name="Jack Bond" userId="d0613b4d9d68792d" providerId="LiveId" clId="{DAEA3D54-AD02-4E1B-A73A-AB467D915B21}"/>
     <pc:docChg chg="undo custSel addSld delSld modSld sldOrd">
-      <pc:chgData name="Jack Bond" userId="d0613b4d9d68792d" providerId="LiveId" clId="{DAEA3D54-AD02-4E1B-A73A-AB467D915B21}" dt="2026-09-22T05:39:22.829" v="1789" actId="1076"/>
+      <pc:chgData name="Jack Bond" userId="d0613b4d9d68792d" providerId="LiveId" clId="{DAEA3D54-AD02-4E1B-A73A-AB467D915B21}" dt="2026-09-22T22:11:43.703" v="2697" actId="1076"/>
       <pc:docMkLst>
         <pc:docMk/>
       </pc:docMkLst>
+      <pc:sldChg chg="addSp delSp modSp add del mod">
+        <pc:chgData name="Jack Bond" userId="d0613b4d9d68792d" providerId="LiveId" clId="{DAEA3D54-AD02-4E1B-A73A-AB467D915B21}" dt="2026-09-22T22:06:53.368" v="2477" actId="20577"/>
+        <pc:sldMkLst>
+          <pc:docMk/>
+          <pc:sldMk cId="0" sldId="256"/>
+        </pc:sldMkLst>
+        <pc:spChg chg="mod">
+          <ac:chgData name="Jack Bond" userId="d0613b4d9d68792d" providerId="LiveId" clId="{DAEA3D54-AD02-4E1B-A73A-AB467D915B21}" dt="2026-09-22T21:59:30.563" v="1856" actId="688"/>
+          <ac:spMkLst>
+            <pc:docMk/>
+            <pc:sldMk cId="0" sldId="256"/>
+            <ac:spMk id="3" creationId="{00000000-0000-0000-0000-000000000000}"/>
+          </ac:spMkLst>
+        </pc:spChg>
+        <pc:spChg chg="add del mod">
+          <ac:chgData name="Jack Bond" userId="d0613b4d9d68792d" providerId="LiveId" clId="{DAEA3D54-AD02-4E1B-A73A-AB467D915B21}" dt="2026-09-22T22:00:06.659" v="1870" actId="21"/>
+          <ac:spMkLst>
+            <pc:docMk/>
+            <pc:sldMk cId="0" sldId="256"/>
+            <ac:spMk id="4" creationId="{D9379EFD-33FF-98A3-F2D2-E88671250F00}"/>
+          </ac:spMkLst>
+        </pc:spChg>
+        <pc:spChg chg="add mod">
+          <ac:chgData name="Jack Bond" userId="d0613b4d9d68792d" providerId="LiveId" clId="{DAEA3D54-AD02-4E1B-A73A-AB467D915B21}" dt="2026-09-22T22:06:53.368" v="2477" actId="20577"/>
+          <ac:spMkLst>
+            <pc:docMk/>
+            <pc:sldMk cId="0" sldId="256"/>
+            <ac:spMk id="6" creationId="{0CEE6955-0FAD-B478-5D4C-7978D7608B2E}"/>
+          </ac:spMkLst>
+        </pc:spChg>
+        <pc:spChg chg="add mod">
+          <ac:chgData name="Jack Bond" userId="d0613b4d9d68792d" providerId="LiveId" clId="{DAEA3D54-AD02-4E1B-A73A-AB467D915B21}" dt="2026-09-22T21:59:30.563" v="1856" actId="688"/>
+          <ac:spMkLst>
+            <pc:docMk/>
+            <pc:sldMk cId="0" sldId="256"/>
+            <ac:spMk id="7" creationId="{DFE27D62-F301-60D3-C2C3-D9D700606B53}"/>
+          </ac:spMkLst>
+        </pc:spChg>
+        <pc:spChg chg="add mod">
+          <ac:chgData name="Jack Bond" userId="d0613b4d9d68792d" providerId="LiveId" clId="{DAEA3D54-AD02-4E1B-A73A-AB467D915B21}" dt="2026-09-22T22:06:42.643" v="2465" actId="20577"/>
+          <ac:spMkLst>
+            <pc:docMk/>
+            <pc:sldMk cId="0" sldId="256"/>
+            <ac:spMk id="8" creationId="{1492B94C-DF15-814E-D148-F886D7063105}"/>
+          </ac:spMkLst>
+        </pc:spChg>
+        <pc:spChg chg="add mod">
+          <ac:chgData name="Jack Bond" userId="d0613b4d9d68792d" providerId="LiveId" clId="{DAEA3D54-AD02-4E1B-A73A-AB467D915B21}" dt="2026-09-22T21:59:30.563" v="1856" actId="688"/>
+          <ac:spMkLst>
+            <pc:docMk/>
+            <pc:sldMk cId="0" sldId="256"/>
+            <ac:spMk id="11" creationId="{B639C6E4-73A5-601B-9F47-EA519C1BBFE4}"/>
+          </ac:spMkLst>
+        </pc:spChg>
+        <pc:spChg chg="add mod">
+          <ac:chgData name="Jack Bond" userId="d0613b4d9d68792d" providerId="LiveId" clId="{DAEA3D54-AD02-4E1B-A73A-AB467D915B21}" dt="2026-09-22T21:59:30.563" v="1856" actId="688"/>
+          <ac:spMkLst>
+            <pc:docMk/>
+            <pc:sldMk cId="0" sldId="256"/>
+            <ac:spMk id="15" creationId="{6805BE46-4303-6924-CFA7-623066ABA631}"/>
+          </ac:spMkLst>
+        </pc:spChg>
+        <pc:spChg chg="add del mod">
+          <ac:chgData name="Jack Bond" userId="d0613b4d9d68792d" providerId="LiveId" clId="{DAEA3D54-AD02-4E1B-A73A-AB467D915B21}" dt="2026-09-22T21:59:27.062" v="1841" actId="22"/>
+          <ac:spMkLst>
+            <pc:docMk/>
+            <pc:sldMk cId="0" sldId="256"/>
+            <ac:spMk id="19" creationId="{DEC0C008-F482-71BE-53E9-61BCB8B47F64}"/>
+          </ac:spMkLst>
+        </pc:spChg>
+        <pc:picChg chg="mod">
+          <ac:chgData name="Jack Bond" userId="d0613b4d9d68792d" providerId="LiveId" clId="{DAEA3D54-AD02-4E1B-A73A-AB467D915B21}" dt="2026-09-22T21:59:30.563" v="1856" actId="688"/>
+          <ac:picMkLst>
+            <pc:docMk/>
+            <pc:sldMk cId="0" sldId="256"/>
+            <ac:picMk id="2" creationId="{00000000-0000-0000-0000-000000000000}"/>
+          </ac:picMkLst>
+        </pc:picChg>
+        <pc:picChg chg="add mod">
+          <ac:chgData name="Jack Bond" userId="d0613b4d9d68792d" providerId="LiveId" clId="{DAEA3D54-AD02-4E1B-A73A-AB467D915B21}" dt="2026-09-22T21:59:30.563" v="1856" actId="688"/>
+          <ac:picMkLst>
+            <pc:docMk/>
+            <pc:sldMk cId="0" sldId="256"/>
+            <ac:picMk id="5" creationId="{9282F49E-C5B9-6024-5490-71DFFE727E15}"/>
+          </ac:picMkLst>
+        </pc:picChg>
+        <pc:picChg chg="add mod">
+          <ac:chgData name="Jack Bond" userId="d0613b4d9d68792d" providerId="LiveId" clId="{DAEA3D54-AD02-4E1B-A73A-AB467D915B21}" dt="2026-09-22T21:59:30.563" v="1856" actId="688"/>
+          <ac:picMkLst>
+            <pc:docMk/>
+            <pc:sldMk cId="0" sldId="256"/>
+            <ac:picMk id="9" creationId="{9BD2E9FF-063E-DFE4-C5BD-D80972F0648D}"/>
+          </ac:picMkLst>
+        </pc:picChg>
+        <pc:picChg chg="add mod">
+          <ac:chgData name="Jack Bond" userId="d0613b4d9d68792d" providerId="LiveId" clId="{DAEA3D54-AD02-4E1B-A73A-AB467D915B21}" dt="2026-09-22T21:59:30.563" v="1856" actId="688"/>
+          <ac:picMkLst>
+            <pc:docMk/>
+            <pc:sldMk cId="0" sldId="256"/>
+            <ac:picMk id="13" creationId="{32885304-5BB2-CA42-AA20-64A87958E263}"/>
+          </ac:picMkLst>
+        </pc:picChg>
+        <pc:picChg chg="add del mod">
+          <ac:chgData name="Jack Bond" userId="d0613b4d9d68792d" providerId="LiveId" clId="{DAEA3D54-AD02-4E1B-A73A-AB467D915B21}" dt="2026-09-22T21:59:27.062" v="1841" actId="22"/>
+          <ac:picMkLst>
+            <pc:docMk/>
+            <pc:sldMk cId="0" sldId="256"/>
+            <ac:picMk id="17" creationId="{398BA2EE-A82A-A169-6199-AC1686BF3E88}"/>
+          </ac:picMkLst>
+        </pc:picChg>
+      </pc:sldChg>
+      <pc:sldChg chg="addSp delSp modSp add del mod">
+        <pc:chgData name="Jack Bond" userId="d0613b4d9d68792d" providerId="LiveId" clId="{DAEA3D54-AD02-4E1B-A73A-AB467D915B21}" dt="2026-09-22T22:09:55.874" v="2654" actId="21"/>
+        <pc:sldMkLst>
+          <pc:docMk/>
+          <pc:sldMk cId="0" sldId="257"/>
+        </pc:sldMkLst>
+        <pc:spChg chg="add del">
+          <ac:chgData name="Jack Bond" userId="d0613b4d9d68792d" providerId="LiveId" clId="{DAEA3D54-AD02-4E1B-A73A-AB467D915B21}" dt="2026-09-22T22:09:55.874" v="2654" actId="21"/>
+          <ac:spMkLst>
+            <pc:docMk/>
+            <pc:sldMk cId="0" sldId="257"/>
+            <ac:spMk id="3" creationId="{00000000-0000-0000-0000-000000000000}"/>
+          </ac:spMkLst>
+        </pc:spChg>
+        <pc:spChg chg="add del mod">
+          <ac:chgData name="Jack Bond" userId="d0613b4d9d68792d" providerId="LiveId" clId="{DAEA3D54-AD02-4E1B-A73A-AB467D915B21}" dt="2026-09-22T22:09:55.874" v="2654" actId="21"/>
+          <ac:spMkLst>
+            <pc:docMk/>
+            <pc:sldMk cId="0" sldId="257"/>
+            <ac:spMk id="5" creationId="{0658CE70-89F2-4472-A8CD-D0C1E1411B38}"/>
+          </ac:spMkLst>
+        </pc:spChg>
+        <pc:spChg chg="add del mod">
+          <ac:chgData name="Jack Bond" userId="d0613b4d9d68792d" providerId="LiveId" clId="{DAEA3D54-AD02-4E1B-A73A-AB467D915B21}" dt="2026-09-22T22:09:55.874" v="2654" actId="21"/>
+          <ac:spMkLst>
+            <pc:docMk/>
+            <pc:sldMk cId="0" sldId="257"/>
+            <ac:spMk id="7" creationId="{572543EC-E8E6-89BE-3462-4DBE8D9F18F0}"/>
+          </ac:spMkLst>
+        </pc:spChg>
+        <pc:spChg chg="add del mod">
+          <ac:chgData name="Jack Bond" userId="d0613b4d9d68792d" providerId="LiveId" clId="{DAEA3D54-AD02-4E1B-A73A-AB467D915B21}" dt="2026-09-22T21:54:29.274" v="1805" actId="21"/>
+          <ac:spMkLst>
+            <pc:docMk/>
+            <pc:sldMk cId="0" sldId="257"/>
+            <ac:spMk id="7" creationId="{F822E703-4614-A728-6937-AA895426EDBD}"/>
+          </ac:spMkLst>
+        </pc:spChg>
+        <pc:picChg chg="add del">
+          <ac:chgData name="Jack Bond" userId="d0613b4d9d68792d" providerId="LiveId" clId="{DAEA3D54-AD02-4E1B-A73A-AB467D915B21}" dt="2026-09-22T22:09:55.874" v="2654" actId="21"/>
+          <ac:picMkLst>
+            <pc:docMk/>
+            <pc:sldMk cId="0" sldId="257"/>
+            <ac:picMk id="2" creationId="{00000000-0000-0000-0000-000000000000}"/>
+          </ac:picMkLst>
+        </pc:picChg>
+        <pc:picChg chg="add del mod">
+          <ac:chgData name="Jack Bond" userId="d0613b4d9d68792d" providerId="LiveId" clId="{DAEA3D54-AD02-4E1B-A73A-AB467D915B21}" dt="2026-09-22T21:54:29.274" v="1805" actId="21"/>
+          <ac:picMkLst>
+            <pc:docMk/>
+            <pc:sldMk cId="0" sldId="257"/>
+            <ac:picMk id="5" creationId="{1C20596C-E4DA-6A23-2187-409B9CCAA8F0}"/>
+          </ac:picMkLst>
+        </pc:picChg>
+      </pc:sldChg>
+      <pc:sldChg chg="addSp delSp modSp add del mod">
+        <pc:chgData name="Jack Bond" userId="d0613b4d9d68792d" providerId="LiveId" clId="{DAEA3D54-AD02-4E1B-A73A-AB467D915B21}" dt="2026-09-22T22:06:05.953" v="2437" actId="1076"/>
+        <pc:sldMkLst>
+          <pc:docMk/>
+          <pc:sldMk cId="0" sldId="258"/>
+        </pc:sldMkLst>
+        <pc:spChg chg="del">
+          <ac:chgData name="Jack Bond" userId="d0613b4d9d68792d" providerId="LiveId" clId="{DAEA3D54-AD02-4E1B-A73A-AB467D915B21}" dt="2026-09-22T21:54:25.795" v="1802" actId="21"/>
+          <ac:spMkLst>
+            <pc:docMk/>
+            <pc:sldMk cId="0" sldId="258"/>
+            <ac:spMk id="3" creationId="{00000000-0000-0000-0000-000000000000}"/>
+          </ac:spMkLst>
+        </pc:spChg>
+        <pc:spChg chg="add mod">
+          <ac:chgData name="Jack Bond" userId="d0613b4d9d68792d" providerId="LiveId" clId="{DAEA3D54-AD02-4E1B-A73A-AB467D915B21}" dt="2026-09-22T22:06:05.953" v="2437" actId="1076"/>
+          <ac:spMkLst>
+            <pc:docMk/>
+            <pc:sldMk cId="0" sldId="258"/>
+            <ac:spMk id="5" creationId="{E9770FD6-CDBB-BBB2-9A4C-5FB01791D330}"/>
+          </ac:spMkLst>
+        </pc:spChg>
+        <pc:spChg chg="add mod">
+          <ac:chgData name="Jack Bond" userId="d0613b4d9d68792d" providerId="LiveId" clId="{DAEA3D54-AD02-4E1B-A73A-AB467D915B21}" dt="2026-09-22T22:06:05.953" v="2437" actId="1076"/>
+          <ac:spMkLst>
+            <pc:docMk/>
+            <pc:sldMk cId="0" sldId="258"/>
+            <ac:spMk id="7" creationId="{76980A52-8B19-9B23-6EFD-ACB89D1546B8}"/>
+          </ac:spMkLst>
+        </pc:spChg>
+        <pc:picChg chg="del">
+          <ac:chgData name="Jack Bond" userId="d0613b4d9d68792d" providerId="LiveId" clId="{DAEA3D54-AD02-4E1B-A73A-AB467D915B21}" dt="2026-09-22T21:54:25.795" v="1802" actId="21"/>
+          <ac:picMkLst>
+            <pc:docMk/>
+            <pc:sldMk cId="0" sldId="258"/>
+            <ac:picMk id="2" creationId="{00000000-0000-0000-0000-000000000000}"/>
+          </ac:picMkLst>
+        </pc:picChg>
+      </pc:sldChg>
+      <pc:sldChg chg="addSp delSp modSp add del mod">
+        <pc:chgData name="Jack Bond" userId="d0613b4d9d68792d" providerId="LiveId" clId="{DAEA3D54-AD02-4E1B-A73A-AB467D915B21}" dt="2026-09-22T22:09:26.740" v="2647" actId="20577"/>
+        <pc:sldMkLst>
+          <pc:docMk/>
+          <pc:sldMk cId="0" sldId="259"/>
+        </pc:sldMkLst>
+        <pc:spChg chg="del">
+          <ac:chgData name="Jack Bond" userId="d0613b4d9d68792d" providerId="LiveId" clId="{DAEA3D54-AD02-4E1B-A73A-AB467D915B21}" dt="2026-09-22T21:54:40.599" v="1809" actId="21"/>
+          <ac:spMkLst>
+            <pc:docMk/>
+            <pc:sldMk cId="0" sldId="259"/>
+            <ac:spMk id="3" creationId="{00000000-0000-0000-0000-000000000000}"/>
+          </ac:spMkLst>
+        </pc:spChg>
+        <pc:spChg chg="add mod">
+          <ac:chgData name="Jack Bond" userId="d0613b4d9d68792d" providerId="LiveId" clId="{DAEA3D54-AD02-4E1B-A73A-AB467D915B21}" dt="2026-09-22T22:08:57.533" v="2608" actId="20577"/>
+          <ac:spMkLst>
+            <pc:docMk/>
+            <pc:sldMk cId="0" sldId="259"/>
+            <ac:spMk id="5" creationId="{E127183E-DF1C-49AE-A54D-04408308903D}"/>
+          </ac:spMkLst>
+        </pc:spChg>
+        <pc:spChg chg="add mod">
+          <ac:chgData name="Jack Bond" userId="d0613b4d9d68792d" providerId="LiveId" clId="{DAEA3D54-AD02-4E1B-A73A-AB467D915B21}" dt="2026-09-22T22:09:26.740" v="2647" actId="20577"/>
+          <ac:spMkLst>
+            <pc:docMk/>
+            <pc:sldMk cId="0" sldId="259"/>
+            <ac:spMk id="7" creationId="{020F595C-E242-7DBD-FB64-E5F650F57B1C}"/>
+          </ac:spMkLst>
+        </pc:spChg>
+        <pc:picChg chg="del">
+          <ac:chgData name="Jack Bond" userId="d0613b4d9d68792d" providerId="LiveId" clId="{DAEA3D54-AD02-4E1B-A73A-AB467D915B21}" dt="2026-09-22T21:54:40.599" v="1809" actId="21"/>
+          <ac:picMkLst>
+            <pc:docMk/>
+            <pc:sldMk cId="0" sldId="259"/>
+            <ac:picMk id="2" creationId="{00000000-0000-0000-0000-000000000000}"/>
+          </ac:picMkLst>
+        </pc:picChg>
+      </pc:sldChg>
+      <pc:sldChg chg="addSp delSp modSp add del mod">
+        <pc:chgData name="Jack Bond" userId="d0613b4d9d68792d" providerId="LiveId" clId="{DAEA3D54-AD02-4E1B-A73A-AB467D915B21}" dt="2026-09-22T22:09:21.292" v="2645" actId="20577"/>
+        <pc:sldMkLst>
+          <pc:docMk/>
+          <pc:sldMk cId="0" sldId="260"/>
+        </pc:sldMkLst>
+        <pc:spChg chg="add del">
+          <ac:chgData name="Jack Bond" userId="d0613b4d9d68792d" providerId="LiveId" clId="{DAEA3D54-AD02-4E1B-A73A-AB467D915B21}" dt="2026-09-22T21:59:27.299" v="1842" actId="21"/>
+          <ac:spMkLst>
+            <pc:docMk/>
+            <pc:sldMk cId="0" sldId="260"/>
+            <ac:spMk id="3" creationId="{00000000-0000-0000-0000-000000000000}"/>
+          </ac:spMkLst>
+        </pc:spChg>
+        <pc:spChg chg="add mod">
+          <ac:chgData name="Jack Bond" userId="d0613b4d9d68792d" providerId="LiveId" clId="{DAEA3D54-AD02-4E1B-A73A-AB467D915B21}" dt="2026-09-22T22:09:14.049" v="2636" actId="20577"/>
+          <ac:spMkLst>
+            <pc:docMk/>
+            <pc:sldMk cId="0" sldId="260"/>
+            <ac:spMk id="5" creationId="{44B0A112-D641-56F9-B12D-6E6112BF68F1}"/>
+          </ac:spMkLst>
+        </pc:spChg>
+        <pc:spChg chg="add mod">
+          <ac:chgData name="Jack Bond" userId="d0613b4d9d68792d" providerId="LiveId" clId="{DAEA3D54-AD02-4E1B-A73A-AB467D915B21}" dt="2026-09-22T22:09:21.292" v="2645" actId="20577"/>
+          <ac:spMkLst>
+            <pc:docMk/>
+            <pc:sldMk cId="0" sldId="260"/>
+            <ac:spMk id="7" creationId="{EBC81F54-1C71-088A-3039-8B02B9B3D5B4}"/>
+          </ac:spMkLst>
+        </pc:spChg>
+        <pc:picChg chg="add del">
+          <ac:chgData name="Jack Bond" userId="d0613b4d9d68792d" providerId="LiveId" clId="{DAEA3D54-AD02-4E1B-A73A-AB467D915B21}" dt="2026-09-22T21:59:27.299" v="1842" actId="21"/>
+          <ac:picMkLst>
+            <pc:docMk/>
+            <pc:sldMk cId="0" sldId="260"/>
+            <ac:picMk id="2" creationId="{00000000-0000-0000-0000-000000000000}"/>
+          </ac:picMkLst>
+        </pc:picChg>
+      </pc:sldChg>
       <pc:sldChg chg="addSp delSp modSp add del mod">
         <pc:chgData name="Jack Bond" userId="d0613b4d9d68792d" providerId="LiveId" clId="{DAEA3D54-AD02-4E1B-A73A-AB467D915B21}" dt="2026-09-22T05:39:22.829" v="1789" actId="1076"/>
         <pc:sldMkLst>
@@ -244,6 +533,117 @@
             <pc:docMk/>
             <pc:sldMk cId="3253799267" sldId="280"/>
             <ac:picMk id="7" creationId="{6A88A0EA-111D-8816-993C-82AF84AD0B9A}"/>
+          </ac:picMkLst>
+        </pc:picChg>
+      </pc:sldChg>
+      <pc:sldChg chg="addSp delSp modSp new mod">
+        <pc:chgData name="Jack Bond" userId="d0613b4d9d68792d" providerId="LiveId" clId="{DAEA3D54-AD02-4E1B-A73A-AB467D915B21}" dt="2026-09-22T22:11:43.703" v="2697" actId="1076"/>
+        <pc:sldMkLst>
+          <pc:docMk/>
+          <pc:sldMk cId="3062071287" sldId="281"/>
+        </pc:sldMkLst>
+        <pc:spChg chg="add del">
+          <ac:chgData name="Jack Bond" userId="d0613b4d9d68792d" providerId="LiveId" clId="{DAEA3D54-AD02-4E1B-A73A-AB467D915B21}" dt="2026-09-22T22:11:01.307" v="2681" actId="22"/>
+          <ac:spMkLst>
+            <pc:docMk/>
+            <pc:sldMk cId="3062071287" sldId="281"/>
+            <ac:spMk id="11" creationId="{2673A4AB-33E9-6BBD-62F0-68F5559B0E6F}"/>
+          </ac:spMkLst>
+        </pc:spChg>
+        <pc:spChg chg="add del">
+          <ac:chgData name="Jack Bond" userId="d0613b4d9d68792d" providerId="LiveId" clId="{DAEA3D54-AD02-4E1B-A73A-AB467D915B21}" dt="2026-09-22T22:11:01.307" v="2681" actId="22"/>
+          <ac:spMkLst>
+            <pc:docMk/>
+            <pc:sldMk cId="3062071287" sldId="281"/>
+            <ac:spMk id="13" creationId="{62204EBB-7AAA-10AA-6EA4-24E1FF3B683C}"/>
+          </ac:spMkLst>
+        </pc:spChg>
+        <pc:spChg chg="add del">
+          <ac:chgData name="Jack Bond" userId="d0613b4d9d68792d" providerId="LiveId" clId="{DAEA3D54-AD02-4E1B-A73A-AB467D915B21}" dt="2026-09-22T22:11:01.307" v="2681" actId="22"/>
+          <ac:spMkLst>
+            <pc:docMk/>
+            <pc:sldMk cId="3062071287" sldId="281"/>
+            <ac:spMk id="15" creationId="{6F6A5B37-1DDA-31B1-C154-CD2BA306D51D}"/>
+          </ac:spMkLst>
+        </pc:spChg>
+        <pc:spChg chg="add del">
+          <ac:chgData name="Jack Bond" userId="d0613b4d9d68792d" providerId="LiveId" clId="{DAEA3D54-AD02-4E1B-A73A-AB467D915B21}" dt="2026-09-22T22:11:33.997" v="2694" actId="22"/>
+          <ac:spMkLst>
+            <pc:docMk/>
+            <pc:sldMk cId="3062071287" sldId="281"/>
+            <ac:spMk id="21" creationId="{3E0265BB-460B-5B3A-1B14-17F1D393AAAA}"/>
+          </ac:spMkLst>
+        </pc:spChg>
+        <pc:spChg chg="add del">
+          <ac:chgData name="Jack Bond" userId="d0613b4d9d68792d" providerId="LiveId" clId="{DAEA3D54-AD02-4E1B-A73A-AB467D915B21}" dt="2026-09-22T22:11:33.997" v="2694" actId="22"/>
+          <ac:spMkLst>
+            <pc:docMk/>
+            <pc:sldMk cId="3062071287" sldId="281"/>
+            <ac:spMk id="23" creationId="{8EEC9F5B-9E22-C27E-F9DC-DFA9D4BC07A3}"/>
+          </ac:spMkLst>
+        </pc:spChg>
+        <pc:spChg chg="add del">
+          <ac:chgData name="Jack Bond" userId="d0613b4d9d68792d" providerId="LiveId" clId="{DAEA3D54-AD02-4E1B-A73A-AB467D915B21}" dt="2026-09-22T22:11:33.997" v="2694" actId="22"/>
+          <ac:spMkLst>
+            <pc:docMk/>
+            <pc:sldMk cId="3062071287" sldId="281"/>
+            <ac:spMk id="25" creationId="{476FF4E2-6AAB-281D-AA86-84B4C906C34B}"/>
+          </ac:spMkLst>
+        </pc:spChg>
+        <pc:picChg chg="add mod">
+          <ac:chgData name="Jack Bond" userId="d0613b4d9d68792d" providerId="LiveId" clId="{DAEA3D54-AD02-4E1B-A73A-AB467D915B21}" dt="2026-09-22T22:10:19.882" v="2668" actId="1076"/>
+          <ac:picMkLst>
+            <pc:docMk/>
+            <pc:sldMk cId="3062071287" sldId="281"/>
+            <ac:picMk id="3" creationId="{1A066A87-E68F-B148-3066-736B3B832C31}"/>
+          </ac:picMkLst>
+        </pc:picChg>
+        <pc:picChg chg="add mod">
+          <ac:chgData name="Jack Bond" userId="d0613b4d9d68792d" providerId="LiveId" clId="{DAEA3D54-AD02-4E1B-A73A-AB467D915B21}" dt="2026-09-22T22:11:20.262" v="2690" actId="1076"/>
+          <ac:picMkLst>
+            <pc:docMk/>
+            <pc:sldMk cId="3062071287" sldId="281"/>
+            <ac:picMk id="5" creationId="{76AEF19E-7BF0-6994-AD7B-44B5DE44AAFF}"/>
+          </ac:picMkLst>
+        </pc:picChg>
+        <pc:picChg chg="add mod">
+          <ac:chgData name="Jack Bond" userId="d0613b4d9d68792d" providerId="LiveId" clId="{DAEA3D54-AD02-4E1B-A73A-AB467D915B21}" dt="2026-09-22T22:11:24.903" v="2692" actId="1076"/>
+          <ac:picMkLst>
+            <pc:docMk/>
+            <pc:sldMk cId="3062071287" sldId="281"/>
+            <ac:picMk id="7" creationId="{0E57FAE8-B4E4-9807-D583-F9D91F2738C2}"/>
+          </ac:picMkLst>
+        </pc:picChg>
+        <pc:picChg chg="add del">
+          <ac:chgData name="Jack Bond" userId="d0613b4d9d68792d" providerId="LiveId" clId="{DAEA3D54-AD02-4E1B-A73A-AB467D915B21}" dt="2026-09-22T22:11:01.307" v="2681" actId="22"/>
+          <ac:picMkLst>
+            <pc:docMk/>
+            <pc:sldMk cId="3062071287" sldId="281"/>
+            <ac:picMk id="9" creationId="{2EC1EFD3-CBAF-B463-EB1B-74063F4D07A4}"/>
+          </ac:picMkLst>
+        </pc:picChg>
+        <pc:picChg chg="add mod">
+          <ac:chgData name="Jack Bond" userId="d0613b4d9d68792d" providerId="LiveId" clId="{DAEA3D54-AD02-4E1B-A73A-AB467D915B21}" dt="2026-09-22T22:11:17.759" v="2688" actId="1076"/>
+          <ac:picMkLst>
+            <pc:docMk/>
+            <pc:sldMk cId="3062071287" sldId="281"/>
+            <ac:picMk id="17" creationId="{42902FD4-431E-69D3-268E-A008810FCCA4}"/>
+          </ac:picMkLst>
+        </pc:picChg>
+        <pc:picChg chg="add del">
+          <ac:chgData name="Jack Bond" userId="d0613b4d9d68792d" providerId="LiveId" clId="{DAEA3D54-AD02-4E1B-A73A-AB467D915B21}" dt="2026-09-22T22:11:33.997" v="2694" actId="22"/>
+          <ac:picMkLst>
+            <pc:docMk/>
+            <pc:sldMk cId="3062071287" sldId="281"/>
+            <ac:picMk id="19" creationId="{EA0272FC-F8A1-1BFE-3685-913E6F6C4665}"/>
+          </ac:picMkLst>
+        </pc:picChg>
+        <pc:picChg chg="add mod">
+          <ac:chgData name="Jack Bond" userId="d0613b4d9d68792d" providerId="LiveId" clId="{DAEA3D54-AD02-4E1B-A73A-AB467D915B21}" dt="2026-09-22T22:11:43.703" v="2697" actId="1076"/>
+          <ac:picMkLst>
+            <pc:docMk/>
+            <pc:sldMk cId="3062071287" sldId="281"/>
+            <ac:picMk id="27" creationId="{967CC89A-512D-F082-0771-82BFB213DDA7}"/>
           </ac:picMkLst>
         </pc:picChg>
       </pc:sldChg>
@@ -3328,6 +3728,1693 @@
 </p:sld>
 </file>
 
+<file path=ppt/slides/slide3.xml><?xml version="1.0" encoding="utf-8"?>
+<p:sld xmlns:a="http://schemas.openxmlformats.org/drawingml/2006/main" xmlns:r="http://schemas.openxmlformats.org/officeDocument/2006/relationships" xmlns:p="http://schemas.openxmlformats.org/presentationml/2006/main">
+  <p:cSld>
+    <p:spTree>
+      <p:nvGrpSpPr>
+        <p:cNvPr id="1" name=""/>
+        <p:cNvGrpSpPr/>
+        <p:nvPr/>
+      </p:nvGrpSpPr>
+      <p:grpSpPr>
+        <a:xfrm>
+          <a:off x="0" y="0"/>
+          <a:ext cx="0" cy="0"/>
+          <a:chOff x="0" y="0"/>
+          <a:chExt cx="0" cy="0"/>
+        </a:xfrm>
+      </p:grpSpPr>
+      <p:pic>
+        <p:nvPicPr>
+          <p:cNvPr id="3" name="Picture 2">
+            <a:extLst>
+              <a:ext uri="{FF2B5EF4-FFF2-40B4-BE49-F238E27FC236}">
+                <a16:creationId xmlns:a16="http://schemas.microsoft.com/office/drawing/2014/main" id="{1A066A87-E68F-B148-3066-736B3B832C31}"/>
+              </a:ext>
+            </a:extLst>
+          </p:cNvPr>
+          <p:cNvPicPr>
+            <a:picLocks noChangeAspect="1"/>
+          </p:cNvPicPr>
+          <p:nvPr/>
+        </p:nvPicPr>
+        <p:blipFill>
+          <a:blip r:embed="rId2"/>
+          <a:stretch>
+            <a:fillRect/>
+          </a:stretch>
+        </p:blipFill>
+        <p:spPr>
+          <a:xfrm rot="5400000">
+            <a:off x="821736" y="-327696"/>
+            <a:ext cx="2987622" cy="4181151"/>
+          </a:xfrm>
+          <a:prstGeom prst="rect">
+            <a:avLst/>
+          </a:prstGeom>
+        </p:spPr>
+      </p:pic>
+      <p:pic>
+        <p:nvPicPr>
+          <p:cNvPr id="5" name="Picture 4">
+            <a:extLst>
+              <a:ext uri="{FF2B5EF4-FFF2-40B4-BE49-F238E27FC236}">
+                <a16:creationId xmlns:a16="http://schemas.microsoft.com/office/drawing/2014/main" id="{76AEF19E-7BF0-6994-AD7B-44B5DE44AAFF}"/>
+              </a:ext>
+            </a:extLst>
+          </p:cNvPr>
+          <p:cNvPicPr>
+            <a:picLocks noChangeAspect="1"/>
+          </p:cNvPicPr>
+          <p:nvPr/>
+        </p:nvPicPr>
+        <p:blipFill>
+          <a:blip r:embed="rId3"/>
+          <a:stretch>
+            <a:fillRect/>
+          </a:stretch>
+        </p:blipFill>
+        <p:spPr>
+          <a:xfrm>
+            <a:off x="4559807" y="602897"/>
+            <a:ext cx="2987621" cy="4181148"/>
+          </a:xfrm>
+          <a:prstGeom prst="rect">
+            <a:avLst/>
+          </a:prstGeom>
+        </p:spPr>
+      </p:pic>
+      <p:pic>
+        <p:nvPicPr>
+          <p:cNvPr id="7" name="Picture 6">
+            <a:extLst>
+              <a:ext uri="{FF2B5EF4-FFF2-40B4-BE49-F238E27FC236}">
+                <a16:creationId xmlns:a16="http://schemas.microsoft.com/office/drawing/2014/main" id="{0E57FAE8-B4E4-9807-D583-F9D91F2738C2}"/>
+              </a:ext>
+            </a:extLst>
+          </p:cNvPr>
+          <p:cNvPicPr>
+            <a:picLocks noChangeAspect="1"/>
+          </p:cNvPicPr>
+          <p:nvPr/>
+        </p:nvPicPr>
+        <p:blipFill>
+          <a:blip r:embed="rId4"/>
+          <a:stretch>
+            <a:fillRect/>
+          </a:stretch>
+        </p:blipFill>
+        <p:spPr>
+          <a:xfrm rot="5400000">
+            <a:off x="808379" y="6204947"/>
+            <a:ext cx="2987621" cy="4181148"/>
+          </a:xfrm>
+          <a:prstGeom prst="rect">
+            <a:avLst/>
+          </a:prstGeom>
+        </p:spPr>
+      </p:pic>
+      <p:pic>
+        <p:nvPicPr>
+          <p:cNvPr id="17" name="Picture 16">
+            <a:extLst>
+              <a:ext uri="{FF2B5EF4-FFF2-40B4-BE49-F238E27FC236}">
+                <a16:creationId xmlns:a16="http://schemas.microsoft.com/office/drawing/2014/main" id="{42902FD4-431E-69D3-268E-A008810FCCA4}"/>
+              </a:ext>
+            </a:extLst>
+          </p:cNvPr>
+          <p:cNvPicPr>
+            <a:picLocks noChangeAspect="1"/>
+          </p:cNvPicPr>
+          <p:nvPr/>
+        </p:nvPicPr>
+        <p:blipFill>
+          <a:blip r:embed="rId5"/>
+          <a:stretch>
+            <a:fillRect/>
+          </a:stretch>
+        </p:blipFill>
+        <p:spPr>
+          <a:xfrm rot="5400000">
+            <a:off x="821734" y="2938625"/>
+            <a:ext cx="2987621" cy="4181149"/>
+          </a:xfrm>
+          <a:prstGeom prst="rect">
+            <a:avLst/>
+          </a:prstGeom>
+        </p:spPr>
+      </p:pic>
+      <p:pic>
+        <p:nvPicPr>
+          <p:cNvPr id="27" name="Picture 26">
+            <a:extLst>
+              <a:ext uri="{FF2B5EF4-FFF2-40B4-BE49-F238E27FC236}">
+                <a16:creationId xmlns:a16="http://schemas.microsoft.com/office/drawing/2014/main" id="{967CC89A-512D-F082-0771-82BFB213DDA7}"/>
+              </a:ext>
+            </a:extLst>
+          </p:cNvPr>
+          <p:cNvPicPr>
+            <a:picLocks noChangeAspect="1"/>
+          </p:cNvPicPr>
+          <p:nvPr/>
+        </p:nvPicPr>
+        <p:blipFill>
+          <a:blip r:embed="rId6"/>
+          <a:stretch>
+            <a:fillRect/>
+          </a:stretch>
+        </p:blipFill>
+        <p:spPr>
+          <a:xfrm>
+            <a:off x="4559807" y="5274356"/>
+            <a:ext cx="2987620" cy="4181148"/>
+          </a:xfrm>
+          <a:prstGeom prst="rect">
+            <a:avLst/>
+          </a:prstGeom>
+        </p:spPr>
+      </p:pic>
+    </p:spTree>
+    <p:extLst>
+      <p:ext uri="{BB962C8B-B14F-4D97-AF65-F5344CB8AC3E}">
+        <p14:creationId xmlns:p14="http://schemas.microsoft.com/office/powerpoint/2010/main" val="3062071287"/>
+      </p:ext>
+    </p:extLst>
+  </p:cSld>
+  <p:clrMapOvr>
+    <a:masterClrMapping/>
+  </p:clrMapOvr>
+</p:sld>
+</file>
+
+<file path=ppt/slides/slide4.xml><?xml version="1.0" encoding="utf-8"?>
+<p:sld xmlns:a="http://schemas.openxmlformats.org/drawingml/2006/main" xmlns:r="http://schemas.openxmlformats.org/officeDocument/2006/relationships" xmlns:p="http://schemas.openxmlformats.org/presentationml/2006/main">
+  <p:cSld>
+    <p:spTree>
+      <p:nvGrpSpPr>
+        <p:cNvPr id="1" name=""/>
+        <p:cNvGrpSpPr/>
+        <p:nvPr/>
+      </p:nvGrpSpPr>
+      <p:grpSpPr>
+        <a:xfrm>
+          <a:off x="0" y="0"/>
+          <a:ext cx="0" cy="0"/>
+          <a:chOff x="0" y="0"/>
+          <a:chExt cx="0" cy="0"/>
+        </a:xfrm>
+      </p:grpSpPr>
+      <p:pic>
+        <p:nvPicPr>
+          <p:cNvPr id="2" name="Picture 1" descr="shimmer_spell_card_1.png"/>
+          <p:cNvPicPr>
+            <a:picLocks noChangeAspect="1"/>
+          </p:cNvPicPr>
+          <p:nvPr/>
+        </p:nvPicPr>
+        <p:blipFill>
+          <a:blip r:embed="rId2"/>
+          <a:stretch>
+            <a:fillRect/>
+          </a:stretch>
+        </p:blipFill>
+        <p:spPr>
+          <a:xfrm>
+            <a:off x="293915" y="0"/>
+            <a:ext cx="7184571" cy="10058400"/>
+          </a:xfrm>
+          <a:prstGeom prst="rect">
+            <a:avLst/>
+          </a:prstGeom>
+        </p:spPr>
+      </p:pic>
+      <p:sp>
+        <p:nvSpPr>
+          <p:cNvPr id="3" name="TextBox 2"/>
+          <p:cNvSpPr txBox="1"/>
+          <p:nvPr/>
+        </p:nvSpPr>
+        <p:spPr>
+          <a:xfrm>
+            <a:off x="1615876" y="1235747"/>
+            <a:ext cx="184731" cy="527709"/>
+          </a:xfrm>
+          <a:prstGeom prst="rect">
+            <a:avLst/>
+          </a:prstGeom>
+          <a:noFill/>
+          <a:ln>
+            <a:noFill/>
+          </a:ln>
+        </p:spPr>
+        <p:txBody>
+          <a:bodyPr wrap="none">
+            <a:spAutoFit/>
+          </a:bodyPr>
+          <a:lstStyle/>
+          <a:p>
+            <a:endParaRPr sz="2829"/>
+          </a:p>
+        </p:txBody>
+      </p:sp>
+      <p:sp>
+        <p:nvSpPr>
+          <p:cNvPr id="6" name="TextBox 5">
+            <a:extLst>
+              <a:ext uri="{FF2B5EF4-FFF2-40B4-BE49-F238E27FC236}">
+                <a16:creationId xmlns:a16="http://schemas.microsoft.com/office/drawing/2014/main" id="{0CEE6955-0FAD-B478-5D4C-7978D7608B2E}"/>
+              </a:ext>
+            </a:extLst>
+          </p:cNvPr>
+          <p:cNvSpPr txBox="1"/>
+          <p:nvPr/>
+        </p:nvSpPr>
+        <p:spPr>
+          <a:xfrm>
+            <a:off x="1574799" y="1440290"/>
+            <a:ext cx="3063659" cy="646331"/>
+          </a:xfrm>
+          <a:prstGeom prst="rect">
+            <a:avLst/>
+          </a:prstGeom>
+          <a:noFill/>
+        </p:spPr>
+        <p:txBody>
+          <a:bodyPr wrap="none" rtlCol="0">
+            <a:spAutoFit/>
+          </a:bodyPr>
+          <a:lstStyle/>
+          <a:p>
+            <a:r>
+              <a:rPr lang="en-US" sz="3600" dirty="0" err="1">
+                <a:latin typeface="Aldhabi" panose="020F0502020204030204" pitchFamily="2" charset="-78"/>
+                <a:cs typeface="Aldhabi" panose="020F0502020204030204" pitchFamily="2" charset="-78"/>
+              </a:rPr>
+              <a:t>Gilothy</a:t>
+            </a:r>
+            <a:r>
+              <a:rPr lang="en-US" sz="3600" dirty="0">
+                <a:latin typeface="Aldhabi" panose="020F0502020204030204" pitchFamily="2" charset="-78"/>
+                <a:cs typeface="Aldhabi" panose="020F0502020204030204" pitchFamily="2" charset="-78"/>
+              </a:rPr>
+              <a:t> </a:t>
+            </a:r>
+            <a:r>
+              <a:rPr lang="en-US" sz="3600" dirty="0" err="1">
+                <a:latin typeface="Aldhabi" panose="020F0502020204030204" pitchFamily="2" charset="-78"/>
+                <a:cs typeface="Aldhabi" panose="020F0502020204030204" pitchFamily="2" charset="-78"/>
+              </a:rPr>
+              <a:t>Silarin</a:t>
+            </a:r>
+            <a:r>
+              <a:rPr lang="en-US" sz="3600" dirty="0">
+                <a:latin typeface="Aldhabi" panose="020F0502020204030204" pitchFamily="2" charset="-78"/>
+                <a:cs typeface="Aldhabi" panose="020F0502020204030204" pitchFamily="2" charset="-78"/>
+              </a:rPr>
+              <a:t>, Inspirer</a:t>
+            </a:r>
+          </a:p>
+        </p:txBody>
+      </p:sp>
+      <p:sp>
+        <p:nvSpPr>
+          <p:cNvPr id="8" name="TextBox 7">
+            <a:extLst>
+              <a:ext uri="{FF2B5EF4-FFF2-40B4-BE49-F238E27FC236}">
+                <a16:creationId xmlns:a16="http://schemas.microsoft.com/office/drawing/2014/main" id="{1492B94C-DF15-814E-D148-F886D7063105}"/>
+              </a:ext>
+            </a:extLst>
+          </p:cNvPr>
+          <p:cNvSpPr txBox="1"/>
+          <p:nvPr/>
+        </p:nvSpPr>
+        <p:spPr>
+          <a:xfrm>
+            <a:off x="1574799" y="2432033"/>
+            <a:ext cx="4622802" cy="6124754"/>
+          </a:xfrm>
+          <a:prstGeom prst="rect">
+            <a:avLst/>
+          </a:prstGeom>
+          <a:noFill/>
+        </p:spPr>
+        <p:txBody>
+          <a:bodyPr wrap="square">
+            <a:spAutoFit/>
+          </a:bodyPr>
+          <a:lstStyle/>
+          <a:p>
+            <a:pPr algn="just"/>
+            <a:r>
+              <a:rPr lang="en-US" sz="2800" dirty="0">
+                <a:latin typeface="Aldhabi" panose="020F0502020204030204" pitchFamily="2" charset="-78"/>
+                <a:cs typeface="Aldhabi" panose="020F0502020204030204" pitchFamily="2" charset="-78"/>
+              </a:rPr>
+              <a:t>You immediately gain 2 levels.</a:t>
+            </a:r>
+          </a:p>
+          <a:p>
+            <a:pPr algn="just"/>
+            <a:endParaRPr lang="en-US" sz="2800" dirty="0">
+              <a:latin typeface="Aldhabi" panose="020F0502020204030204" pitchFamily="2" charset="-78"/>
+              <a:cs typeface="Aldhabi" panose="020F0502020204030204" pitchFamily="2" charset="-78"/>
+            </a:endParaRPr>
+          </a:p>
+          <a:p>
+            <a:pPr algn="just"/>
+            <a:r>
+              <a:rPr lang="en-US" sz="2800" dirty="0">
+                <a:latin typeface="Aldhabi" panose="020F0502020204030204" pitchFamily="2" charset="-78"/>
+                <a:cs typeface="Aldhabi" panose="020F0502020204030204" pitchFamily="2" charset="-78"/>
+              </a:rPr>
+              <a:t>For 24 hours you gain the following effects</a:t>
+            </a:r>
+          </a:p>
+          <a:p>
+            <a:pPr marL="285750" indent="-285750" algn="just">
+              <a:buFont typeface="Arial" panose="020B0604020202020204" pitchFamily="34" charset="0"/>
+              <a:buChar char="•"/>
+            </a:pPr>
+            <a:r>
+              <a:rPr lang="en-US" sz="2800" dirty="0">
+                <a:latin typeface="Aldhabi" panose="020F0502020204030204" pitchFamily="2" charset="-78"/>
+                <a:cs typeface="Aldhabi" panose="020F0502020204030204" pitchFamily="2" charset="-78"/>
+              </a:rPr>
+              <a:t>You gain 50 temporary hit points.</a:t>
+            </a:r>
+          </a:p>
+          <a:p>
+            <a:pPr marL="285750" indent="-285750" algn="just">
+              <a:buFont typeface="Arial" panose="020B0604020202020204" pitchFamily="34" charset="0"/>
+              <a:buChar char="•"/>
+            </a:pPr>
+            <a:r>
+              <a:rPr lang="en-US" sz="2800" dirty="0">
+                <a:latin typeface="Aldhabi" panose="020F0502020204030204" pitchFamily="2" charset="-78"/>
+                <a:cs typeface="Aldhabi" panose="020F0502020204030204" pitchFamily="2" charset="-78"/>
+              </a:rPr>
+              <a:t>You gain 10ft to your walking speed.</a:t>
+            </a:r>
+          </a:p>
+          <a:p>
+            <a:pPr marL="285750" indent="-285750" algn="just">
+              <a:buFont typeface="Arial" panose="020B0604020202020204" pitchFamily="34" charset="0"/>
+              <a:buChar char="•"/>
+            </a:pPr>
+            <a:r>
+              <a:rPr lang="en-US" sz="2800" dirty="0">
+                <a:latin typeface="Aldhabi" panose="020F0502020204030204" pitchFamily="2" charset="-78"/>
+                <a:cs typeface="Aldhabi" panose="020F0502020204030204" pitchFamily="2" charset="-78"/>
+              </a:rPr>
+              <a:t>You ignore plant-based difficult terrain.</a:t>
+            </a:r>
+          </a:p>
+          <a:p>
+            <a:pPr marL="285750" indent="-285750" algn="just">
+              <a:buFont typeface="Arial" panose="020B0604020202020204" pitchFamily="34" charset="0"/>
+              <a:buChar char="•"/>
+            </a:pPr>
+            <a:r>
+              <a:rPr lang="en-US" sz="2800" i="1" dirty="0" err="1">
+                <a:latin typeface="Aldhabi" panose="020F0502020204030204" pitchFamily="2" charset="-78"/>
+                <a:cs typeface="Aldhabi" panose="020F0502020204030204" pitchFamily="2" charset="-78"/>
+              </a:rPr>
+              <a:t>Skinsplinterers</a:t>
+            </a:r>
+            <a:r>
+              <a:rPr lang="en-US" sz="2800" dirty="0">
+                <a:latin typeface="Aldhabi" panose="020F0502020204030204" pitchFamily="2" charset="-78"/>
+                <a:cs typeface="Aldhabi" panose="020F0502020204030204" pitchFamily="2" charset="-78"/>
+              </a:rPr>
+              <a:t> are vulnerable to your attack damage.</a:t>
+            </a:r>
+          </a:p>
+          <a:p>
+            <a:pPr marL="285750" indent="-285750" algn="just">
+              <a:buFont typeface="Arial" panose="020B0604020202020204" pitchFamily="34" charset="0"/>
+              <a:buChar char="•"/>
+            </a:pPr>
+            <a:r>
+              <a:rPr lang="en-US" sz="2800" i="1" dirty="0" err="1">
+                <a:latin typeface="Aldhabi" panose="020F0502020204030204" pitchFamily="2" charset="-78"/>
+                <a:cs typeface="Aldhabi" panose="020F0502020204030204" pitchFamily="2" charset="-78"/>
+              </a:rPr>
+              <a:t>Skinsplinterers</a:t>
+            </a:r>
+            <a:r>
+              <a:rPr lang="en-US" sz="2800" dirty="0">
+                <a:latin typeface="Aldhabi" panose="020F0502020204030204" pitchFamily="2" charset="-78"/>
+                <a:cs typeface="Aldhabi" panose="020F0502020204030204" pitchFamily="2" charset="-78"/>
+              </a:rPr>
+              <a:t> have disadvantage on saving throws against your spells.</a:t>
+            </a:r>
+          </a:p>
+          <a:p>
+            <a:pPr algn="just"/>
+            <a:endParaRPr lang="en-US" sz="2800" dirty="0">
+              <a:latin typeface="Aldhabi" panose="020F0502020204030204" pitchFamily="2" charset="-78"/>
+              <a:cs typeface="Aldhabi" panose="020F0502020204030204" pitchFamily="2" charset="-78"/>
+            </a:endParaRPr>
+          </a:p>
+          <a:p>
+            <a:pPr algn="just"/>
+            <a:r>
+              <a:rPr lang="en-US" sz="2800" dirty="0">
+                <a:latin typeface="Aldhabi" panose="020F0502020204030204" pitchFamily="2" charset="-78"/>
+                <a:cs typeface="Aldhabi" panose="020F0502020204030204" pitchFamily="2" charset="-78"/>
+              </a:rPr>
+              <a:t>Additionally, you may cast the spell </a:t>
+            </a:r>
+            <a:r>
+              <a:rPr lang="en-US" sz="2800" i="1" dirty="0">
+                <a:latin typeface="Aldhabi" panose="020F0502020204030204" pitchFamily="2" charset="-78"/>
+                <a:cs typeface="Aldhabi" panose="020F0502020204030204" pitchFamily="2" charset="-78"/>
+              </a:rPr>
+              <a:t>Mass Heal </a:t>
+            </a:r>
+            <a:r>
+              <a:rPr lang="en-US" sz="2800" dirty="0">
+                <a:latin typeface="Aldhabi" panose="020F0502020204030204" pitchFamily="2" charset="-78"/>
+                <a:cs typeface="Aldhabi" panose="020F0502020204030204" pitchFamily="2" charset="-78"/>
+              </a:rPr>
+              <a:t>once without a spell slot or material components.</a:t>
+            </a:r>
+          </a:p>
+        </p:txBody>
+      </p:sp>
+    </p:spTree>
+  </p:cSld>
+  <p:clrMapOvr>
+    <a:masterClrMapping/>
+  </p:clrMapOvr>
+</p:sld>
+</file>
+
+<file path=ppt/slides/slide5.xml><?xml version="1.0" encoding="utf-8"?>
+<p:sld xmlns:a="http://schemas.openxmlformats.org/drawingml/2006/main" xmlns:r="http://schemas.openxmlformats.org/officeDocument/2006/relationships" xmlns:p="http://schemas.openxmlformats.org/presentationml/2006/main">
+  <p:cSld>
+    <p:spTree>
+      <p:nvGrpSpPr>
+        <p:cNvPr id="1" name=""/>
+        <p:cNvGrpSpPr/>
+        <p:nvPr/>
+      </p:nvGrpSpPr>
+      <p:grpSpPr>
+        <a:xfrm>
+          <a:off x="0" y="0"/>
+          <a:ext cx="0" cy="0"/>
+          <a:chOff x="0" y="0"/>
+          <a:chExt cx="0" cy="0"/>
+        </a:xfrm>
+      </p:grpSpPr>
+      <p:pic>
+        <p:nvPicPr>
+          <p:cNvPr id="2" name="Picture 1" descr="shimmer_spell_card_2.png"/>
+          <p:cNvPicPr>
+            <a:picLocks noChangeAspect="1"/>
+          </p:cNvPicPr>
+          <p:nvPr/>
+        </p:nvPicPr>
+        <p:blipFill>
+          <a:blip r:embed="rId2"/>
+          <a:stretch>
+            <a:fillRect/>
+          </a:stretch>
+        </p:blipFill>
+        <p:spPr>
+          <a:xfrm>
+            <a:off x="293915" y="0"/>
+            <a:ext cx="7184571" cy="10058400"/>
+          </a:xfrm>
+          <a:prstGeom prst="rect">
+            <a:avLst/>
+          </a:prstGeom>
+        </p:spPr>
+      </p:pic>
+      <p:sp>
+        <p:nvSpPr>
+          <p:cNvPr id="3" name="TextBox 2"/>
+          <p:cNvSpPr txBox="1"/>
+          <p:nvPr/>
+        </p:nvSpPr>
+        <p:spPr>
+          <a:xfrm>
+            <a:off x="1615876" y="1235747"/>
+            <a:ext cx="184731" cy="527709"/>
+          </a:xfrm>
+          <a:prstGeom prst="rect">
+            <a:avLst/>
+          </a:prstGeom>
+          <a:noFill/>
+          <a:ln>
+            <a:noFill/>
+          </a:ln>
+        </p:spPr>
+        <p:txBody>
+          <a:bodyPr wrap="none">
+            <a:spAutoFit/>
+          </a:bodyPr>
+          <a:lstStyle/>
+          <a:p>
+            <a:endParaRPr sz="2829"/>
+          </a:p>
+        </p:txBody>
+      </p:sp>
+      <p:sp>
+        <p:nvSpPr>
+          <p:cNvPr id="5" name="TextBox 4">
+            <a:extLst>
+              <a:ext uri="{FF2B5EF4-FFF2-40B4-BE49-F238E27FC236}">
+                <a16:creationId xmlns:a16="http://schemas.microsoft.com/office/drawing/2014/main" id="{0658CE70-89F2-4472-A8CD-D0C1E1411B38}"/>
+              </a:ext>
+            </a:extLst>
+          </p:cNvPr>
+          <p:cNvSpPr txBox="1"/>
+          <p:nvPr/>
+        </p:nvSpPr>
+        <p:spPr>
+          <a:xfrm>
+            <a:off x="1574799" y="1440290"/>
+            <a:ext cx="3403496" cy="646331"/>
+          </a:xfrm>
+          <a:prstGeom prst="rect">
+            <a:avLst/>
+          </a:prstGeom>
+          <a:noFill/>
+        </p:spPr>
+        <p:txBody>
+          <a:bodyPr wrap="none" rtlCol="0">
+            <a:spAutoFit/>
+          </a:bodyPr>
+          <a:lstStyle/>
+          <a:p>
+            <a:r>
+              <a:rPr lang="en-US" sz="3600" dirty="0">
+                <a:latin typeface="Aldhabi" panose="020F0502020204030204" pitchFamily="2" charset="-78"/>
+                <a:cs typeface="Aldhabi" panose="020F0502020204030204" pitchFamily="2" charset="-78"/>
+              </a:rPr>
+              <a:t>Petunia, Peerless </a:t>
+            </a:r>
+            <a:r>
+              <a:rPr lang="en-US" sz="3600" dirty="0" err="1">
+                <a:latin typeface="Aldhabi" panose="020F0502020204030204" pitchFamily="2" charset="-78"/>
+                <a:cs typeface="Aldhabi" panose="020F0502020204030204" pitchFamily="2" charset="-78"/>
+              </a:rPr>
+              <a:t>Tactitian</a:t>
+            </a:r>
+            <a:endParaRPr lang="en-US" sz="3600" dirty="0">
+              <a:latin typeface="Aldhabi" panose="020F0502020204030204" pitchFamily="2" charset="-78"/>
+              <a:cs typeface="Aldhabi" panose="020F0502020204030204" pitchFamily="2" charset="-78"/>
+            </a:endParaRPr>
+          </a:p>
+        </p:txBody>
+      </p:sp>
+      <p:sp>
+        <p:nvSpPr>
+          <p:cNvPr id="7" name="TextBox 6">
+            <a:extLst>
+              <a:ext uri="{FF2B5EF4-FFF2-40B4-BE49-F238E27FC236}">
+                <a16:creationId xmlns:a16="http://schemas.microsoft.com/office/drawing/2014/main" id="{572543EC-E8E6-89BE-3462-4DBE8D9F18F0}"/>
+              </a:ext>
+            </a:extLst>
+          </p:cNvPr>
+          <p:cNvSpPr txBox="1"/>
+          <p:nvPr/>
+        </p:nvSpPr>
+        <p:spPr>
+          <a:xfrm>
+            <a:off x="1574799" y="2432033"/>
+            <a:ext cx="4622802" cy="6124754"/>
+          </a:xfrm>
+          <a:prstGeom prst="rect">
+            <a:avLst/>
+          </a:prstGeom>
+          <a:noFill/>
+        </p:spPr>
+        <p:txBody>
+          <a:bodyPr wrap="square">
+            <a:spAutoFit/>
+          </a:bodyPr>
+          <a:lstStyle/>
+          <a:p>
+            <a:pPr algn="just"/>
+            <a:r>
+              <a:rPr lang="en-US" sz="2800" dirty="0">
+                <a:latin typeface="Aldhabi" panose="020F0502020204030204" pitchFamily="2" charset="-78"/>
+                <a:cs typeface="Aldhabi" panose="020F0502020204030204" pitchFamily="2" charset="-78"/>
+              </a:rPr>
+              <a:t>You immediately gain 2 levels.</a:t>
+            </a:r>
+          </a:p>
+          <a:p>
+            <a:pPr algn="just"/>
+            <a:endParaRPr lang="en-US" sz="2800" dirty="0">
+              <a:latin typeface="Aldhabi" panose="020F0502020204030204" pitchFamily="2" charset="-78"/>
+              <a:cs typeface="Aldhabi" panose="020F0502020204030204" pitchFamily="2" charset="-78"/>
+            </a:endParaRPr>
+          </a:p>
+          <a:p>
+            <a:pPr algn="just"/>
+            <a:r>
+              <a:rPr lang="en-US" sz="2800" dirty="0">
+                <a:latin typeface="Aldhabi" panose="020F0502020204030204" pitchFamily="2" charset="-78"/>
+                <a:cs typeface="Aldhabi" panose="020F0502020204030204" pitchFamily="2" charset="-78"/>
+              </a:rPr>
+              <a:t>For 24 hours you gain the following effects</a:t>
+            </a:r>
+          </a:p>
+          <a:p>
+            <a:pPr marL="285750" indent="-285750" algn="just">
+              <a:buFont typeface="Arial" panose="020B0604020202020204" pitchFamily="34" charset="0"/>
+              <a:buChar char="•"/>
+            </a:pPr>
+            <a:r>
+              <a:rPr lang="en-US" sz="2800" dirty="0">
+                <a:latin typeface="Aldhabi" panose="020F0502020204030204" pitchFamily="2" charset="-78"/>
+                <a:cs typeface="Aldhabi" panose="020F0502020204030204" pitchFamily="2" charset="-78"/>
+              </a:rPr>
+              <a:t>You gain 50 temporary hit points.</a:t>
+            </a:r>
+          </a:p>
+          <a:p>
+            <a:pPr marL="285750" indent="-285750" algn="just">
+              <a:buFont typeface="Arial" panose="020B0604020202020204" pitchFamily="34" charset="0"/>
+              <a:buChar char="•"/>
+            </a:pPr>
+            <a:r>
+              <a:rPr lang="en-US" sz="2800" dirty="0">
+                <a:latin typeface="Aldhabi" panose="020F0502020204030204" pitchFamily="2" charset="-78"/>
+                <a:cs typeface="Aldhabi" panose="020F0502020204030204" pitchFamily="2" charset="-78"/>
+              </a:rPr>
+              <a:t>You gain 10ft to your walking speed.</a:t>
+            </a:r>
+          </a:p>
+          <a:p>
+            <a:pPr marL="285750" indent="-285750" algn="just">
+              <a:buFont typeface="Arial" panose="020B0604020202020204" pitchFamily="34" charset="0"/>
+              <a:buChar char="•"/>
+            </a:pPr>
+            <a:r>
+              <a:rPr lang="en-US" sz="2800" dirty="0">
+                <a:latin typeface="Aldhabi" panose="020F0502020204030204" pitchFamily="2" charset="-78"/>
+                <a:cs typeface="Aldhabi" panose="020F0502020204030204" pitchFamily="2" charset="-78"/>
+              </a:rPr>
+              <a:t>You ignore plant-based difficult terrain.</a:t>
+            </a:r>
+          </a:p>
+          <a:p>
+            <a:pPr marL="285750" indent="-285750" algn="just">
+              <a:buFont typeface="Arial" panose="020B0604020202020204" pitchFamily="34" charset="0"/>
+              <a:buChar char="•"/>
+            </a:pPr>
+            <a:r>
+              <a:rPr lang="en-US" sz="2800" i="1" dirty="0" err="1">
+                <a:latin typeface="Aldhabi" panose="020F0502020204030204" pitchFamily="2" charset="-78"/>
+                <a:cs typeface="Aldhabi" panose="020F0502020204030204" pitchFamily="2" charset="-78"/>
+              </a:rPr>
+              <a:t>Skinsplinterers</a:t>
+            </a:r>
+            <a:r>
+              <a:rPr lang="en-US" sz="2800" dirty="0">
+                <a:latin typeface="Aldhabi" panose="020F0502020204030204" pitchFamily="2" charset="-78"/>
+                <a:cs typeface="Aldhabi" panose="020F0502020204030204" pitchFamily="2" charset="-78"/>
+              </a:rPr>
+              <a:t> are vulnerable to your attack damage.</a:t>
+            </a:r>
+          </a:p>
+          <a:p>
+            <a:pPr marL="285750" indent="-285750" algn="just">
+              <a:buFont typeface="Arial" panose="020B0604020202020204" pitchFamily="34" charset="0"/>
+              <a:buChar char="•"/>
+            </a:pPr>
+            <a:r>
+              <a:rPr lang="en-US" sz="2800" i="1" dirty="0" err="1">
+                <a:latin typeface="Aldhabi" panose="020F0502020204030204" pitchFamily="2" charset="-78"/>
+                <a:cs typeface="Aldhabi" panose="020F0502020204030204" pitchFamily="2" charset="-78"/>
+              </a:rPr>
+              <a:t>Skinsplinterers</a:t>
+            </a:r>
+            <a:r>
+              <a:rPr lang="en-US" sz="2800" dirty="0">
+                <a:latin typeface="Aldhabi" panose="020F0502020204030204" pitchFamily="2" charset="-78"/>
+                <a:cs typeface="Aldhabi" panose="020F0502020204030204" pitchFamily="2" charset="-78"/>
+              </a:rPr>
+              <a:t> have disadvantage on saving throws against your spells.</a:t>
+            </a:r>
+          </a:p>
+          <a:p>
+            <a:pPr algn="just"/>
+            <a:endParaRPr lang="en-US" sz="2800" dirty="0">
+              <a:latin typeface="Aldhabi" panose="020F0502020204030204" pitchFamily="2" charset="-78"/>
+              <a:cs typeface="Aldhabi" panose="020F0502020204030204" pitchFamily="2" charset="-78"/>
+            </a:endParaRPr>
+          </a:p>
+          <a:p>
+            <a:pPr algn="just"/>
+            <a:r>
+              <a:rPr lang="en-US" sz="2800" dirty="0">
+                <a:latin typeface="Aldhabi" panose="020F0502020204030204" pitchFamily="2" charset="-78"/>
+                <a:cs typeface="Aldhabi" panose="020F0502020204030204" pitchFamily="2" charset="-78"/>
+              </a:rPr>
+              <a:t>Additionally, you may cast the spell </a:t>
+            </a:r>
+            <a:r>
+              <a:rPr lang="en-US" sz="2800" i="1" dirty="0">
+                <a:latin typeface="Aldhabi" panose="020F0502020204030204" pitchFamily="2" charset="-78"/>
+                <a:cs typeface="Aldhabi" panose="020F0502020204030204" pitchFamily="2" charset="-78"/>
+              </a:rPr>
+              <a:t>Foresight </a:t>
+            </a:r>
+            <a:r>
+              <a:rPr lang="en-US" sz="2800" dirty="0">
+                <a:latin typeface="Aldhabi" panose="020F0502020204030204" pitchFamily="2" charset="-78"/>
+                <a:cs typeface="Aldhabi" panose="020F0502020204030204" pitchFamily="2" charset="-78"/>
+              </a:rPr>
+              <a:t>once without a spell slot or material components.</a:t>
+            </a:r>
+          </a:p>
+        </p:txBody>
+      </p:sp>
+    </p:spTree>
+  </p:cSld>
+  <p:clrMapOvr>
+    <a:masterClrMapping/>
+  </p:clrMapOvr>
+</p:sld>
+</file>
+
+<file path=ppt/slides/slide6.xml><?xml version="1.0" encoding="utf-8"?>
+<p:sld xmlns:a="http://schemas.openxmlformats.org/drawingml/2006/main" xmlns:r="http://schemas.openxmlformats.org/officeDocument/2006/relationships" xmlns:p="http://schemas.openxmlformats.org/presentationml/2006/main">
+  <p:cSld>
+    <p:spTree>
+      <p:nvGrpSpPr>
+        <p:cNvPr id="1" name=""/>
+        <p:cNvGrpSpPr/>
+        <p:nvPr/>
+      </p:nvGrpSpPr>
+      <p:grpSpPr>
+        <a:xfrm>
+          <a:off x="0" y="0"/>
+          <a:ext cx="0" cy="0"/>
+          <a:chOff x="0" y="0"/>
+          <a:chExt cx="0" cy="0"/>
+        </a:xfrm>
+      </p:grpSpPr>
+      <p:pic>
+        <p:nvPicPr>
+          <p:cNvPr id="2" name="Picture 1" descr="shimmer_spell_card_3.png"/>
+          <p:cNvPicPr>
+            <a:picLocks noChangeAspect="1"/>
+          </p:cNvPicPr>
+          <p:nvPr/>
+        </p:nvPicPr>
+        <p:blipFill>
+          <a:blip r:embed="rId2"/>
+          <a:stretch>
+            <a:fillRect/>
+          </a:stretch>
+        </p:blipFill>
+        <p:spPr>
+          <a:xfrm>
+            <a:off x="293915" y="0"/>
+            <a:ext cx="7184571" cy="10058400"/>
+          </a:xfrm>
+          <a:prstGeom prst="rect">
+            <a:avLst/>
+          </a:prstGeom>
+        </p:spPr>
+      </p:pic>
+      <p:sp>
+        <p:nvSpPr>
+          <p:cNvPr id="3" name="TextBox 2"/>
+          <p:cNvSpPr txBox="1"/>
+          <p:nvPr/>
+        </p:nvSpPr>
+        <p:spPr>
+          <a:xfrm>
+            <a:off x="1615876" y="1235747"/>
+            <a:ext cx="184731" cy="527709"/>
+          </a:xfrm>
+          <a:prstGeom prst="rect">
+            <a:avLst/>
+          </a:prstGeom>
+          <a:noFill/>
+          <a:ln>
+            <a:noFill/>
+          </a:ln>
+        </p:spPr>
+        <p:txBody>
+          <a:bodyPr wrap="none">
+            <a:spAutoFit/>
+          </a:bodyPr>
+          <a:lstStyle/>
+          <a:p>
+            <a:endParaRPr sz="2829"/>
+          </a:p>
+        </p:txBody>
+      </p:sp>
+      <p:sp>
+        <p:nvSpPr>
+          <p:cNvPr id="5" name="TextBox 4">
+            <a:extLst>
+              <a:ext uri="{FF2B5EF4-FFF2-40B4-BE49-F238E27FC236}">
+                <a16:creationId xmlns:a16="http://schemas.microsoft.com/office/drawing/2014/main" id="{E9770FD6-CDBB-BBB2-9A4C-5FB01791D330}"/>
+              </a:ext>
+            </a:extLst>
+          </p:cNvPr>
+          <p:cNvSpPr txBox="1"/>
+          <p:nvPr/>
+        </p:nvSpPr>
+        <p:spPr>
+          <a:xfrm>
+            <a:off x="1574799" y="1440290"/>
+            <a:ext cx="4278735" cy="646331"/>
+          </a:xfrm>
+          <a:prstGeom prst="rect">
+            <a:avLst/>
+          </a:prstGeom>
+          <a:noFill/>
+        </p:spPr>
+        <p:txBody>
+          <a:bodyPr wrap="none" rtlCol="0">
+            <a:spAutoFit/>
+          </a:bodyPr>
+          <a:lstStyle/>
+          <a:p>
+            <a:r>
+              <a:rPr lang="en-US" sz="3600" dirty="0" err="1">
+                <a:latin typeface="Aldhabi" panose="020F0502020204030204" pitchFamily="2" charset="-78"/>
+                <a:cs typeface="Aldhabi" panose="020F0502020204030204" pitchFamily="2" charset="-78"/>
+              </a:rPr>
+              <a:t>Giahuaghn</a:t>
+            </a:r>
+            <a:r>
+              <a:rPr lang="en-US" sz="3600" dirty="0">
+                <a:latin typeface="Aldhabi" panose="020F0502020204030204" pitchFamily="2" charset="-78"/>
+                <a:cs typeface="Aldhabi" panose="020F0502020204030204" pitchFamily="2" charset="-78"/>
+              </a:rPr>
+              <a:t> </a:t>
+            </a:r>
+            <a:r>
+              <a:rPr lang="en-US" sz="3600" dirty="0" err="1">
+                <a:latin typeface="Aldhabi" panose="020F0502020204030204" pitchFamily="2" charset="-78"/>
+                <a:cs typeface="Aldhabi" panose="020F0502020204030204" pitchFamily="2" charset="-78"/>
+              </a:rPr>
+              <a:t>Nuamor</a:t>
+            </a:r>
+            <a:r>
+              <a:rPr lang="en-US" sz="3600" dirty="0">
+                <a:latin typeface="Aldhabi" panose="020F0502020204030204" pitchFamily="2" charset="-78"/>
+                <a:cs typeface="Aldhabi" panose="020F0502020204030204" pitchFamily="2" charset="-78"/>
+              </a:rPr>
+              <a:t>, </a:t>
+            </a:r>
+            <a:r>
+              <a:rPr lang="en-US" sz="3600" dirty="0" err="1">
+                <a:latin typeface="Aldhabi" panose="020F0502020204030204" pitchFamily="2" charset="-78"/>
+                <a:cs typeface="Aldhabi" panose="020F0502020204030204" pitchFamily="2" charset="-78"/>
+              </a:rPr>
+              <a:t>Deathstealer</a:t>
+            </a:r>
+            <a:endParaRPr lang="en-US" sz="3600" dirty="0">
+              <a:latin typeface="Aldhabi" panose="020F0502020204030204" pitchFamily="2" charset="-78"/>
+              <a:cs typeface="Aldhabi" panose="020F0502020204030204" pitchFamily="2" charset="-78"/>
+            </a:endParaRPr>
+          </a:p>
+        </p:txBody>
+      </p:sp>
+      <p:sp>
+        <p:nvSpPr>
+          <p:cNvPr id="7" name="TextBox 6">
+            <a:extLst>
+              <a:ext uri="{FF2B5EF4-FFF2-40B4-BE49-F238E27FC236}">
+                <a16:creationId xmlns:a16="http://schemas.microsoft.com/office/drawing/2014/main" id="{76980A52-8B19-9B23-6EFD-ACB89D1546B8}"/>
+              </a:ext>
+            </a:extLst>
+          </p:cNvPr>
+          <p:cNvSpPr txBox="1"/>
+          <p:nvPr/>
+        </p:nvSpPr>
+        <p:spPr>
+          <a:xfrm>
+            <a:off x="1574799" y="2432033"/>
+            <a:ext cx="4622802" cy="6124754"/>
+          </a:xfrm>
+          <a:prstGeom prst="rect">
+            <a:avLst/>
+          </a:prstGeom>
+          <a:noFill/>
+        </p:spPr>
+        <p:txBody>
+          <a:bodyPr wrap="square">
+            <a:spAutoFit/>
+          </a:bodyPr>
+          <a:lstStyle/>
+          <a:p>
+            <a:pPr algn="just"/>
+            <a:r>
+              <a:rPr lang="en-US" sz="2800" dirty="0">
+                <a:latin typeface="Aldhabi" panose="020F0502020204030204" pitchFamily="2" charset="-78"/>
+                <a:cs typeface="Aldhabi" panose="020F0502020204030204" pitchFamily="2" charset="-78"/>
+              </a:rPr>
+              <a:t>You immediately gain 2 levels.</a:t>
+            </a:r>
+          </a:p>
+          <a:p>
+            <a:pPr algn="just"/>
+            <a:endParaRPr lang="en-US" sz="2800" dirty="0">
+              <a:latin typeface="Aldhabi" panose="020F0502020204030204" pitchFamily="2" charset="-78"/>
+              <a:cs typeface="Aldhabi" panose="020F0502020204030204" pitchFamily="2" charset="-78"/>
+            </a:endParaRPr>
+          </a:p>
+          <a:p>
+            <a:pPr algn="just"/>
+            <a:r>
+              <a:rPr lang="en-US" sz="2800" dirty="0">
+                <a:latin typeface="Aldhabi" panose="020F0502020204030204" pitchFamily="2" charset="-78"/>
+                <a:cs typeface="Aldhabi" panose="020F0502020204030204" pitchFamily="2" charset="-78"/>
+              </a:rPr>
+              <a:t>For 24 hours you gain the following effects</a:t>
+            </a:r>
+          </a:p>
+          <a:p>
+            <a:pPr marL="285750" indent="-285750" algn="just">
+              <a:buFont typeface="Arial" panose="020B0604020202020204" pitchFamily="34" charset="0"/>
+              <a:buChar char="•"/>
+            </a:pPr>
+            <a:r>
+              <a:rPr lang="en-US" sz="2800" dirty="0">
+                <a:latin typeface="Aldhabi" panose="020F0502020204030204" pitchFamily="2" charset="-78"/>
+                <a:cs typeface="Aldhabi" panose="020F0502020204030204" pitchFamily="2" charset="-78"/>
+              </a:rPr>
+              <a:t>You gain 50 temporary hit points.</a:t>
+            </a:r>
+          </a:p>
+          <a:p>
+            <a:pPr marL="285750" indent="-285750" algn="just">
+              <a:buFont typeface="Arial" panose="020B0604020202020204" pitchFamily="34" charset="0"/>
+              <a:buChar char="•"/>
+            </a:pPr>
+            <a:r>
+              <a:rPr lang="en-US" sz="2800" dirty="0">
+                <a:latin typeface="Aldhabi" panose="020F0502020204030204" pitchFamily="2" charset="-78"/>
+                <a:cs typeface="Aldhabi" panose="020F0502020204030204" pitchFamily="2" charset="-78"/>
+              </a:rPr>
+              <a:t>You gain 10ft to your walking speed.</a:t>
+            </a:r>
+          </a:p>
+          <a:p>
+            <a:pPr marL="285750" indent="-285750" algn="just">
+              <a:buFont typeface="Arial" panose="020B0604020202020204" pitchFamily="34" charset="0"/>
+              <a:buChar char="•"/>
+            </a:pPr>
+            <a:r>
+              <a:rPr lang="en-US" sz="2800" dirty="0">
+                <a:latin typeface="Aldhabi" panose="020F0502020204030204" pitchFamily="2" charset="-78"/>
+                <a:cs typeface="Aldhabi" panose="020F0502020204030204" pitchFamily="2" charset="-78"/>
+              </a:rPr>
+              <a:t>You ignore plant-based difficult terrain.</a:t>
+            </a:r>
+          </a:p>
+          <a:p>
+            <a:pPr marL="285750" indent="-285750" algn="just">
+              <a:buFont typeface="Arial" panose="020B0604020202020204" pitchFamily="34" charset="0"/>
+              <a:buChar char="•"/>
+            </a:pPr>
+            <a:r>
+              <a:rPr lang="en-US" sz="2800" i="1" dirty="0" err="1">
+                <a:latin typeface="Aldhabi" panose="020F0502020204030204" pitchFamily="2" charset="-78"/>
+                <a:cs typeface="Aldhabi" panose="020F0502020204030204" pitchFamily="2" charset="-78"/>
+              </a:rPr>
+              <a:t>Skinsplinterers</a:t>
+            </a:r>
+            <a:r>
+              <a:rPr lang="en-US" sz="2800" dirty="0">
+                <a:latin typeface="Aldhabi" panose="020F0502020204030204" pitchFamily="2" charset="-78"/>
+                <a:cs typeface="Aldhabi" panose="020F0502020204030204" pitchFamily="2" charset="-78"/>
+              </a:rPr>
+              <a:t> are vulnerable to your attack damage.</a:t>
+            </a:r>
+          </a:p>
+          <a:p>
+            <a:pPr marL="285750" indent="-285750" algn="just">
+              <a:buFont typeface="Arial" panose="020B0604020202020204" pitchFamily="34" charset="0"/>
+              <a:buChar char="•"/>
+            </a:pPr>
+            <a:r>
+              <a:rPr lang="en-US" sz="2800" i="1" dirty="0" err="1">
+                <a:latin typeface="Aldhabi" panose="020F0502020204030204" pitchFamily="2" charset="-78"/>
+                <a:cs typeface="Aldhabi" panose="020F0502020204030204" pitchFamily="2" charset="-78"/>
+              </a:rPr>
+              <a:t>Skinsplinterers</a:t>
+            </a:r>
+            <a:r>
+              <a:rPr lang="en-US" sz="2800" dirty="0">
+                <a:latin typeface="Aldhabi" panose="020F0502020204030204" pitchFamily="2" charset="-78"/>
+                <a:cs typeface="Aldhabi" panose="020F0502020204030204" pitchFamily="2" charset="-78"/>
+              </a:rPr>
+              <a:t> have disadvantage on saving throws against your spells.</a:t>
+            </a:r>
+          </a:p>
+          <a:p>
+            <a:pPr algn="just"/>
+            <a:endParaRPr lang="en-US" sz="2800" dirty="0">
+              <a:latin typeface="Aldhabi" panose="020F0502020204030204" pitchFamily="2" charset="-78"/>
+              <a:cs typeface="Aldhabi" panose="020F0502020204030204" pitchFamily="2" charset="-78"/>
+            </a:endParaRPr>
+          </a:p>
+          <a:p>
+            <a:pPr algn="just"/>
+            <a:r>
+              <a:rPr lang="en-US" sz="2800" dirty="0">
+                <a:latin typeface="Aldhabi" panose="020F0502020204030204" pitchFamily="2" charset="-78"/>
+                <a:cs typeface="Aldhabi" panose="020F0502020204030204" pitchFamily="2" charset="-78"/>
+              </a:rPr>
+              <a:t>Additionally, you may cast the spell</a:t>
+            </a:r>
+            <a:br>
+              <a:rPr lang="en-US" sz="2800" dirty="0">
+                <a:latin typeface="Aldhabi" panose="020F0502020204030204" pitchFamily="2" charset="-78"/>
+                <a:cs typeface="Aldhabi" panose="020F0502020204030204" pitchFamily="2" charset="-78"/>
+              </a:rPr>
+            </a:br>
+            <a:r>
+              <a:rPr lang="en-US" sz="2800" dirty="0">
+                <a:latin typeface="Aldhabi" panose="020F0502020204030204" pitchFamily="2" charset="-78"/>
+                <a:cs typeface="Aldhabi" panose="020F0502020204030204" pitchFamily="2" charset="-78"/>
+              </a:rPr>
+              <a:t> </a:t>
+            </a:r>
+            <a:r>
+              <a:rPr lang="en-US" sz="2800" i="1" dirty="0">
+                <a:latin typeface="Aldhabi" panose="020F0502020204030204" pitchFamily="2" charset="-78"/>
+                <a:cs typeface="Aldhabi" panose="020F0502020204030204" pitchFamily="2" charset="-78"/>
+              </a:rPr>
+              <a:t>True Resurrection </a:t>
+            </a:r>
+            <a:r>
+              <a:rPr lang="en-US" sz="2800" dirty="0">
+                <a:latin typeface="Aldhabi" panose="020F0502020204030204" pitchFamily="2" charset="-78"/>
+                <a:cs typeface="Aldhabi" panose="020F0502020204030204" pitchFamily="2" charset="-78"/>
+              </a:rPr>
+              <a:t>once without a spell slot or material components.</a:t>
+            </a:r>
+          </a:p>
+        </p:txBody>
+      </p:sp>
+    </p:spTree>
+  </p:cSld>
+  <p:clrMapOvr>
+    <a:masterClrMapping/>
+  </p:clrMapOvr>
+</p:sld>
+</file>
+
+<file path=ppt/slides/slide7.xml><?xml version="1.0" encoding="utf-8"?>
+<p:sld xmlns:a="http://schemas.openxmlformats.org/drawingml/2006/main" xmlns:r="http://schemas.openxmlformats.org/officeDocument/2006/relationships" xmlns:p="http://schemas.openxmlformats.org/presentationml/2006/main">
+  <p:cSld>
+    <p:spTree>
+      <p:nvGrpSpPr>
+        <p:cNvPr id="1" name=""/>
+        <p:cNvGrpSpPr/>
+        <p:nvPr/>
+      </p:nvGrpSpPr>
+      <p:grpSpPr>
+        <a:xfrm>
+          <a:off x="0" y="0"/>
+          <a:ext cx="0" cy="0"/>
+          <a:chOff x="0" y="0"/>
+          <a:chExt cx="0" cy="0"/>
+        </a:xfrm>
+      </p:grpSpPr>
+      <p:pic>
+        <p:nvPicPr>
+          <p:cNvPr id="2" name="Picture 1" descr="shimmer_spell_card_4.png"/>
+          <p:cNvPicPr>
+            <a:picLocks noChangeAspect="1"/>
+          </p:cNvPicPr>
+          <p:nvPr/>
+        </p:nvPicPr>
+        <p:blipFill>
+          <a:blip r:embed="rId2"/>
+          <a:stretch>
+            <a:fillRect/>
+          </a:stretch>
+        </p:blipFill>
+        <p:spPr>
+          <a:xfrm>
+            <a:off x="293915" y="0"/>
+            <a:ext cx="7184571" cy="10058400"/>
+          </a:xfrm>
+          <a:prstGeom prst="rect">
+            <a:avLst/>
+          </a:prstGeom>
+        </p:spPr>
+      </p:pic>
+      <p:sp>
+        <p:nvSpPr>
+          <p:cNvPr id="3" name="TextBox 2"/>
+          <p:cNvSpPr txBox="1"/>
+          <p:nvPr/>
+        </p:nvSpPr>
+        <p:spPr>
+          <a:xfrm>
+            <a:off x="1615876" y="1235747"/>
+            <a:ext cx="184731" cy="527709"/>
+          </a:xfrm>
+          <a:prstGeom prst="rect">
+            <a:avLst/>
+          </a:prstGeom>
+          <a:noFill/>
+          <a:ln>
+            <a:noFill/>
+          </a:ln>
+        </p:spPr>
+        <p:txBody>
+          <a:bodyPr wrap="none">
+            <a:spAutoFit/>
+          </a:bodyPr>
+          <a:lstStyle/>
+          <a:p>
+            <a:endParaRPr sz="2829"/>
+          </a:p>
+        </p:txBody>
+      </p:sp>
+      <p:sp>
+        <p:nvSpPr>
+          <p:cNvPr id="5" name="TextBox 4">
+            <a:extLst>
+              <a:ext uri="{FF2B5EF4-FFF2-40B4-BE49-F238E27FC236}">
+                <a16:creationId xmlns:a16="http://schemas.microsoft.com/office/drawing/2014/main" id="{E127183E-DF1C-49AE-A54D-04408308903D}"/>
+              </a:ext>
+            </a:extLst>
+          </p:cNvPr>
+          <p:cNvSpPr txBox="1"/>
+          <p:nvPr/>
+        </p:nvSpPr>
+        <p:spPr>
+          <a:xfrm>
+            <a:off x="1574799" y="1440290"/>
+            <a:ext cx="3977371" cy="646331"/>
+          </a:xfrm>
+          <a:prstGeom prst="rect">
+            <a:avLst/>
+          </a:prstGeom>
+          <a:noFill/>
+        </p:spPr>
+        <p:txBody>
+          <a:bodyPr wrap="none" rtlCol="0">
+            <a:spAutoFit/>
+          </a:bodyPr>
+          <a:lstStyle/>
+          <a:p>
+            <a:r>
+              <a:rPr lang="en-US" sz="3600" dirty="0">
+                <a:latin typeface="Aldhabi" panose="020F0502020204030204" pitchFamily="2" charset="-78"/>
+                <a:cs typeface="Aldhabi" panose="020F0502020204030204" pitchFamily="2" charset="-78"/>
+              </a:rPr>
+              <a:t>Rivka, Scion of Frost and Wood</a:t>
+            </a:r>
+          </a:p>
+        </p:txBody>
+      </p:sp>
+      <p:sp>
+        <p:nvSpPr>
+          <p:cNvPr id="7" name="TextBox 6">
+            <a:extLst>
+              <a:ext uri="{FF2B5EF4-FFF2-40B4-BE49-F238E27FC236}">
+                <a16:creationId xmlns:a16="http://schemas.microsoft.com/office/drawing/2014/main" id="{020F595C-E242-7DBD-FB64-E5F650F57B1C}"/>
+              </a:ext>
+            </a:extLst>
+          </p:cNvPr>
+          <p:cNvSpPr txBox="1"/>
+          <p:nvPr/>
+        </p:nvSpPr>
+        <p:spPr>
+          <a:xfrm>
+            <a:off x="1574799" y="2432033"/>
+            <a:ext cx="4622802" cy="6124754"/>
+          </a:xfrm>
+          <a:prstGeom prst="rect">
+            <a:avLst/>
+          </a:prstGeom>
+          <a:noFill/>
+        </p:spPr>
+        <p:txBody>
+          <a:bodyPr wrap="square">
+            <a:spAutoFit/>
+          </a:bodyPr>
+          <a:lstStyle/>
+          <a:p>
+            <a:pPr algn="just"/>
+            <a:r>
+              <a:rPr lang="en-US" sz="2800" dirty="0">
+                <a:latin typeface="Aldhabi" panose="020F0502020204030204" pitchFamily="2" charset="-78"/>
+                <a:cs typeface="Aldhabi" panose="020F0502020204030204" pitchFamily="2" charset="-78"/>
+              </a:rPr>
+              <a:t>You immediately gain 2 levels.</a:t>
+            </a:r>
+          </a:p>
+          <a:p>
+            <a:pPr algn="just"/>
+            <a:endParaRPr lang="en-US" sz="2800" dirty="0">
+              <a:latin typeface="Aldhabi" panose="020F0502020204030204" pitchFamily="2" charset="-78"/>
+              <a:cs typeface="Aldhabi" panose="020F0502020204030204" pitchFamily="2" charset="-78"/>
+            </a:endParaRPr>
+          </a:p>
+          <a:p>
+            <a:pPr algn="just"/>
+            <a:r>
+              <a:rPr lang="en-US" sz="2800" dirty="0">
+                <a:latin typeface="Aldhabi" panose="020F0502020204030204" pitchFamily="2" charset="-78"/>
+                <a:cs typeface="Aldhabi" panose="020F0502020204030204" pitchFamily="2" charset="-78"/>
+              </a:rPr>
+              <a:t>For 24 hours you gain the following effects</a:t>
+            </a:r>
+          </a:p>
+          <a:p>
+            <a:pPr marL="285750" indent="-285750" algn="just">
+              <a:buFont typeface="Arial" panose="020B0604020202020204" pitchFamily="34" charset="0"/>
+              <a:buChar char="•"/>
+            </a:pPr>
+            <a:r>
+              <a:rPr lang="en-US" sz="2800" dirty="0">
+                <a:latin typeface="Aldhabi" panose="020F0502020204030204" pitchFamily="2" charset="-78"/>
+                <a:cs typeface="Aldhabi" panose="020F0502020204030204" pitchFamily="2" charset="-78"/>
+              </a:rPr>
+              <a:t>You gain 50 temporary hit points.</a:t>
+            </a:r>
+          </a:p>
+          <a:p>
+            <a:pPr marL="285750" indent="-285750" algn="just">
+              <a:buFont typeface="Arial" panose="020B0604020202020204" pitchFamily="34" charset="0"/>
+              <a:buChar char="•"/>
+            </a:pPr>
+            <a:r>
+              <a:rPr lang="en-US" sz="2800" dirty="0">
+                <a:latin typeface="Aldhabi" panose="020F0502020204030204" pitchFamily="2" charset="-78"/>
+                <a:cs typeface="Aldhabi" panose="020F0502020204030204" pitchFamily="2" charset="-78"/>
+              </a:rPr>
+              <a:t>You gain 10ft to your walking speed.</a:t>
+            </a:r>
+          </a:p>
+          <a:p>
+            <a:pPr marL="285750" indent="-285750" algn="just">
+              <a:buFont typeface="Arial" panose="020B0604020202020204" pitchFamily="34" charset="0"/>
+              <a:buChar char="•"/>
+            </a:pPr>
+            <a:r>
+              <a:rPr lang="en-US" sz="2800" dirty="0">
+                <a:latin typeface="Aldhabi" panose="020F0502020204030204" pitchFamily="2" charset="-78"/>
+                <a:cs typeface="Aldhabi" panose="020F0502020204030204" pitchFamily="2" charset="-78"/>
+              </a:rPr>
+              <a:t>You ignore plant-based difficult terrain.</a:t>
+            </a:r>
+          </a:p>
+          <a:p>
+            <a:pPr marL="285750" indent="-285750" algn="just">
+              <a:buFont typeface="Arial" panose="020B0604020202020204" pitchFamily="34" charset="0"/>
+              <a:buChar char="•"/>
+            </a:pPr>
+            <a:r>
+              <a:rPr lang="en-US" sz="2800" i="1" dirty="0" err="1">
+                <a:latin typeface="Aldhabi" panose="020F0502020204030204" pitchFamily="2" charset="-78"/>
+                <a:cs typeface="Aldhabi" panose="020F0502020204030204" pitchFamily="2" charset="-78"/>
+              </a:rPr>
+              <a:t>Skinsplinterers</a:t>
+            </a:r>
+            <a:r>
+              <a:rPr lang="en-US" sz="2800" dirty="0">
+                <a:latin typeface="Aldhabi" panose="020F0502020204030204" pitchFamily="2" charset="-78"/>
+                <a:cs typeface="Aldhabi" panose="020F0502020204030204" pitchFamily="2" charset="-78"/>
+              </a:rPr>
+              <a:t> are vulnerable to your attack damage.</a:t>
+            </a:r>
+          </a:p>
+          <a:p>
+            <a:pPr marL="285750" indent="-285750" algn="just">
+              <a:buFont typeface="Arial" panose="020B0604020202020204" pitchFamily="34" charset="0"/>
+              <a:buChar char="•"/>
+            </a:pPr>
+            <a:r>
+              <a:rPr lang="en-US" sz="2800" i="1" dirty="0" err="1">
+                <a:latin typeface="Aldhabi" panose="020F0502020204030204" pitchFamily="2" charset="-78"/>
+                <a:cs typeface="Aldhabi" panose="020F0502020204030204" pitchFamily="2" charset="-78"/>
+              </a:rPr>
+              <a:t>Skinsplinterers</a:t>
+            </a:r>
+            <a:r>
+              <a:rPr lang="en-US" sz="2800" dirty="0">
+                <a:latin typeface="Aldhabi" panose="020F0502020204030204" pitchFamily="2" charset="-78"/>
+                <a:cs typeface="Aldhabi" panose="020F0502020204030204" pitchFamily="2" charset="-78"/>
+              </a:rPr>
+              <a:t> have disadvantage on saving throws against your spells.</a:t>
+            </a:r>
+          </a:p>
+          <a:p>
+            <a:pPr algn="just"/>
+            <a:endParaRPr lang="en-US" sz="2800" dirty="0">
+              <a:latin typeface="Aldhabi" panose="020F0502020204030204" pitchFamily="2" charset="-78"/>
+              <a:cs typeface="Aldhabi" panose="020F0502020204030204" pitchFamily="2" charset="-78"/>
+            </a:endParaRPr>
+          </a:p>
+          <a:p>
+            <a:pPr algn="just"/>
+            <a:r>
+              <a:rPr lang="en-US" sz="2800" dirty="0">
+                <a:latin typeface="Aldhabi" panose="020F0502020204030204" pitchFamily="2" charset="-78"/>
+                <a:cs typeface="Aldhabi" panose="020F0502020204030204" pitchFamily="2" charset="-78"/>
+              </a:rPr>
+              <a:t>Additionally, you may cast the spell </a:t>
+            </a:r>
+            <a:r>
+              <a:rPr lang="en-US" sz="2800" i="1" dirty="0" err="1">
+                <a:latin typeface="Aldhabi" panose="020F0502020204030204" pitchFamily="2" charset="-78"/>
+                <a:cs typeface="Aldhabi" panose="020F0502020204030204" pitchFamily="2" charset="-78"/>
+              </a:rPr>
+              <a:t>Shapechange</a:t>
+            </a:r>
+            <a:r>
+              <a:rPr lang="en-US" sz="2800" i="1" dirty="0">
+                <a:latin typeface="Aldhabi" panose="020F0502020204030204" pitchFamily="2" charset="-78"/>
+                <a:cs typeface="Aldhabi" panose="020F0502020204030204" pitchFamily="2" charset="-78"/>
+              </a:rPr>
+              <a:t> </a:t>
+            </a:r>
+            <a:r>
+              <a:rPr lang="en-US" sz="2800" dirty="0">
+                <a:latin typeface="Aldhabi" panose="020F0502020204030204" pitchFamily="2" charset="-78"/>
+                <a:cs typeface="Aldhabi" panose="020F0502020204030204" pitchFamily="2" charset="-78"/>
+              </a:rPr>
+              <a:t>once without a spell slot or material components.</a:t>
+            </a:r>
+          </a:p>
+        </p:txBody>
+      </p:sp>
+    </p:spTree>
+  </p:cSld>
+  <p:clrMapOvr>
+    <a:masterClrMapping/>
+  </p:clrMapOvr>
+</p:sld>
+</file>
+
+<file path=ppt/slides/slide8.xml><?xml version="1.0" encoding="utf-8"?>
+<p:sld xmlns:a="http://schemas.openxmlformats.org/drawingml/2006/main" xmlns:r="http://schemas.openxmlformats.org/officeDocument/2006/relationships" xmlns:p="http://schemas.openxmlformats.org/presentationml/2006/main">
+  <p:cSld>
+    <p:spTree>
+      <p:nvGrpSpPr>
+        <p:cNvPr id="1" name=""/>
+        <p:cNvGrpSpPr/>
+        <p:nvPr/>
+      </p:nvGrpSpPr>
+      <p:grpSpPr>
+        <a:xfrm>
+          <a:off x="0" y="0"/>
+          <a:ext cx="0" cy="0"/>
+          <a:chOff x="0" y="0"/>
+          <a:chExt cx="0" cy="0"/>
+        </a:xfrm>
+      </p:grpSpPr>
+      <p:pic>
+        <p:nvPicPr>
+          <p:cNvPr id="2" name="Picture 1" descr="shimmer_spell_card_5.png"/>
+          <p:cNvPicPr>
+            <a:picLocks noChangeAspect="1"/>
+          </p:cNvPicPr>
+          <p:nvPr/>
+        </p:nvPicPr>
+        <p:blipFill>
+          <a:blip r:embed="rId2"/>
+          <a:stretch>
+            <a:fillRect/>
+          </a:stretch>
+        </p:blipFill>
+        <p:spPr>
+          <a:xfrm>
+            <a:off x="293915" y="0"/>
+            <a:ext cx="7184571" cy="10058400"/>
+          </a:xfrm>
+          <a:prstGeom prst="rect">
+            <a:avLst/>
+          </a:prstGeom>
+        </p:spPr>
+      </p:pic>
+      <p:sp>
+        <p:nvSpPr>
+          <p:cNvPr id="3" name="TextBox 2"/>
+          <p:cNvSpPr txBox="1"/>
+          <p:nvPr/>
+        </p:nvSpPr>
+        <p:spPr>
+          <a:xfrm>
+            <a:off x="1615876" y="1235747"/>
+            <a:ext cx="184731" cy="527709"/>
+          </a:xfrm>
+          <a:prstGeom prst="rect">
+            <a:avLst/>
+          </a:prstGeom>
+          <a:noFill/>
+          <a:ln>
+            <a:noFill/>
+          </a:ln>
+        </p:spPr>
+        <p:txBody>
+          <a:bodyPr wrap="none">
+            <a:spAutoFit/>
+          </a:bodyPr>
+          <a:lstStyle/>
+          <a:p>
+            <a:endParaRPr sz="2829"/>
+          </a:p>
+        </p:txBody>
+      </p:sp>
+      <p:sp>
+        <p:nvSpPr>
+          <p:cNvPr id="5" name="TextBox 4">
+            <a:extLst>
+              <a:ext uri="{FF2B5EF4-FFF2-40B4-BE49-F238E27FC236}">
+                <a16:creationId xmlns:a16="http://schemas.microsoft.com/office/drawing/2014/main" id="{44B0A112-D641-56F9-B12D-6E6112BF68F1}"/>
+              </a:ext>
+            </a:extLst>
+          </p:cNvPr>
+          <p:cNvSpPr txBox="1"/>
+          <p:nvPr/>
+        </p:nvSpPr>
+        <p:spPr>
+          <a:xfrm>
+            <a:off x="1574799" y="1440290"/>
+            <a:ext cx="3462807" cy="646331"/>
+          </a:xfrm>
+          <a:prstGeom prst="rect">
+            <a:avLst/>
+          </a:prstGeom>
+          <a:noFill/>
+        </p:spPr>
+        <p:txBody>
+          <a:bodyPr wrap="none" rtlCol="0">
+            <a:spAutoFit/>
+          </a:bodyPr>
+          <a:lstStyle/>
+          <a:p>
+            <a:r>
+              <a:rPr lang="en-US" sz="3600" dirty="0">
+                <a:latin typeface="Aldhabi" panose="020F0502020204030204" pitchFamily="2" charset="-78"/>
+                <a:cs typeface="Aldhabi" panose="020F0502020204030204" pitchFamily="2" charset="-78"/>
+              </a:rPr>
+              <a:t>Lemm No, Prince of Hearts</a:t>
+            </a:r>
+          </a:p>
+        </p:txBody>
+      </p:sp>
+      <p:sp>
+        <p:nvSpPr>
+          <p:cNvPr id="7" name="TextBox 6">
+            <a:extLst>
+              <a:ext uri="{FF2B5EF4-FFF2-40B4-BE49-F238E27FC236}">
+                <a16:creationId xmlns:a16="http://schemas.microsoft.com/office/drawing/2014/main" id="{EBC81F54-1C71-088A-3039-8B02B9B3D5B4}"/>
+              </a:ext>
+            </a:extLst>
+          </p:cNvPr>
+          <p:cNvSpPr txBox="1"/>
+          <p:nvPr/>
+        </p:nvSpPr>
+        <p:spPr>
+          <a:xfrm>
+            <a:off x="1574799" y="2432033"/>
+            <a:ext cx="4622802" cy="6124754"/>
+          </a:xfrm>
+          <a:prstGeom prst="rect">
+            <a:avLst/>
+          </a:prstGeom>
+          <a:noFill/>
+        </p:spPr>
+        <p:txBody>
+          <a:bodyPr wrap="square">
+            <a:spAutoFit/>
+          </a:bodyPr>
+          <a:lstStyle/>
+          <a:p>
+            <a:pPr algn="just"/>
+            <a:r>
+              <a:rPr lang="en-US" sz="2800" dirty="0">
+                <a:latin typeface="Aldhabi" panose="020F0502020204030204" pitchFamily="2" charset="-78"/>
+                <a:cs typeface="Aldhabi" panose="020F0502020204030204" pitchFamily="2" charset="-78"/>
+              </a:rPr>
+              <a:t>You immediately gain 2 levels.</a:t>
+            </a:r>
+          </a:p>
+          <a:p>
+            <a:pPr algn="just"/>
+            <a:endParaRPr lang="en-US" sz="2800" dirty="0">
+              <a:latin typeface="Aldhabi" panose="020F0502020204030204" pitchFamily="2" charset="-78"/>
+              <a:cs typeface="Aldhabi" panose="020F0502020204030204" pitchFamily="2" charset="-78"/>
+            </a:endParaRPr>
+          </a:p>
+          <a:p>
+            <a:pPr algn="just"/>
+            <a:r>
+              <a:rPr lang="en-US" sz="2800" dirty="0">
+                <a:latin typeface="Aldhabi" panose="020F0502020204030204" pitchFamily="2" charset="-78"/>
+                <a:cs typeface="Aldhabi" panose="020F0502020204030204" pitchFamily="2" charset="-78"/>
+              </a:rPr>
+              <a:t>For 24 hours you gain the following effects</a:t>
+            </a:r>
+          </a:p>
+          <a:p>
+            <a:pPr marL="285750" indent="-285750" algn="just">
+              <a:buFont typeface="Arial" panose="020B0604020202020204" pitchFamily="34" charset="0"/>
+              <a:buChar char="•"/>
+            </a:pPr>
+            <a:r>
+              <a:rPr lang="en-US" sz="2800" dirty="0">
+                <a:latin typeface="Aldhabi" panose="020F0502020204030204" pitchFamily="2" charset="-78"/>
+                <a:cs typeface="Aldhabi" panose="020F0502020204030204" pitchFamily="2" charset="-78"/>
+              </a:rPr>
+              <a:t>You gain 50 temporary hit points.</a:t>
+            </a:r>
+          </a:p>
+          <a:p>
+            <a:pPr marL="285750" indent="-285750" algn="just">
+              <a:buFont typeface="Arial" panose="020B0604020202020204" pitchFamily="34" charset="0"/>
+              <a:buChar char="•"/>
+            </a:pPr>
+            <a:r>
+              <a:rPr lang="en-US" sz="2800" dirty="0">
+                <a:latin typeface="Aldhabi" panose="020F0502020204030204" pitchFamily="2" charset="-78"/>
+                <a:cs typeface="Aldhabi" panose="020F0502020204030204" pitchFamily="2" charset="-78"/>
+              </a:rPr>
+              <a:t>You gain 10ft to your walking speed.</a:t>
+            </a:r>
+          </a:p>
+          <a:p>
+            <a:pPr marL="285750" indent="-285750" algn="just">
+              <a:buFont typeface="Arial" panose="020B0604020202020204" pitchFamily="34" charset="0"/>
+              <a:buChar char="•"/>
+            </a:pPr>
+            <a:r>
+              <a:rPr lang="en-US" sz="2800" dirty="0">
+                <a:latin typeface="Aldhabi" panose="020F0502020204030204" pitchFamily="2" charset="-78"/>
+                <a:cs typeface="Aldhabi" panose="020F0502020204030204" pitchFamily="2" charset="-78"/>
+              </a:rPr>
+              <a:t>You ignore plant-based difficult terrain.</a:t>
+            </a:r>
+          </a:p>
+          <a:p>
+            <a:pPr marL="285750" indent="-285750" algn="just">
+              <a:buFont typeface="Arial" panose="020B0604020202020204" pitchFamily="34" charset="0"/>
+              <a:buChar char="•"/>
+            </a:pPr>
+            <a:r>
+              <a:rPr lang="en-US" sz="2800" i="1" dirty="0" err="1">
+                <a:latin typeface="Aldhabi" panose="020F0502020204030204" pitchFamily="2" charset="-78"/>
+                <a:cs typeface="Aldhabi" panose="020F0502020204030204" pitchFamily="2" charset="-78"/>
+              </a:rPr>
+              <a:t>Skinsplinterers</a:t>
+            </a:r>
+            <a:r>
+              <a:rPr lang="en-US" sz="2800" dirty="0">
+                <a:latin typeface="Aldhabi" panose="020F0502020204030204" pitchFamily="2" charset="-78"/>
+                <a:cs typeface="Aldhabi" panose="020F0502020204030204" pitchFamily="2" charset="-78"/>
+              </a:rPr>
+              <a:t> are vulnerable to your attack damage.</a:t>
+            </a:r>
+          </a:p>
+          <a:p>
+            <a:pPr marL="285750" indent="-285750" algn="just">
+              <a:buFont typeface="Arial" panose="020B0604020202020204" pitchFamily="34" charset="0"/>
+              <a:buChar char="•"/>
+            </a:pPr>
+            <a:r>
+              <a:rPr lang="en-US" sz="2800" i="1" dirty="0" err="1">
+                <a:latin typeface="Aldhabi" panose="020F0502020204030204" pitchFamily="2" charset="-78"/>
+                <a:cs typeface="Aldhabi" panose="020F0502020204030204" pitchFamily="2" charset="-78"/>
+              </a:rPr>
+              <a:t>Skinsplinterers</a:t>
+            </a:r>
+            <a:r>
+              <a:rPr lang="en-US" sz="2800" dirty="0">
+                <a:latin typeface="Aldhabi" panose="020F0502020204030204" pitchFamily="2" charset="-78"/>
+                <a:cs typeface="Aldhabi" panose="020F0502020204030204" pitchFamily="2" charset="-78"/>
+              </a:rPr>
+              <a:t> have disadvantage on saving throws against your spells.</a:t>
+            </a:r>
+          </a:p>
+          <a:p>
+            <a:pPr algn="just"/>
+            <a:endParaRPr lang="en-US" sz="2800" dirty="0">
+              <a:latin typeface="Aldhabi" panose="020F0502020204030204" pitchFamily="2" charset="-78"/>
+              <a:cs typeface="Aldhabi" panose="020F0502020204030204" pitchFamily="2" charset="-78"/>
+            </a:endParaRPr>
+          </a:p>
+          <a:p>
+            <a:pPr algn="just"/>
+            <a:r>
+              <a:rPr lang="en-US" sz="2800" dirty="0">
+                <a:latin typeface="Aldhabi" panose="020F0502020204030204" pitchFamily="2" charset="-78"/>
+                <a:cs typeface="Aldhabi" panose="020F0502020204030204" pitchFamily="2" charset="-78"/>
+              </a:rPr>
+              <a:t>Additionally, you may cast the spell</a:t>
+            </a:r>
+            <a:br>
+              <a:rPr lang="en-US" sz="2800" dirty="0">
+                <a:latin typeface="Aldhabi" panose="020F0502020204030204" pitchFamily="2" charset="-78"/>
+                <a:cs typeface="Aldhabi" panose="020F0502020204030204" pitchFamily="2" charset="-78"/>
+              </a:rPr>
+            </a:br>
+            <a:r>
+              <a:rPr lang="en-US" sz="2800" dirty="0">
+                <a:latin typeface="Aldhabi" panose="020F0502020204030204" pitchFamily="2" charset="-78"/>
+                <a:cs typeface="Aldhabi" panose="020F0502020204030204" pitchFamily="2" charset="-78"/>
+              </a:rPr>
+              <a:t> </a:t>
+            </a:r>
+            <a:r>
+              <a:rPr lang="en-US" sz="2800" i="1" dirty="0">
+                <a:latin typeface="Aldhabi" panose="020F0502020204030204" pitchFamily="2" charset="-78"/>
+                <a:cs typeface="Aldhabi" panose="020F0502020204030204" pitchFamily="2" charset="-78"/>
+              </a:rPr>
+              <a:t>True Polymorph </a:t>
+            </a:r>
+            <a:r>
+              <a:rPr lang="en-US" sz="2800" dirty="0">
+                <a:latin typeface="Aldhabi" panose="020F0502020204030204" pitchFamily="2" charset="-78"/>
+                <a:cs typeface="Aldhabi" panose="020F0502020204030204" pitchFamily="2" charset="-78"/>
+              </a:rPr>
+              <a:t>once without a spell slot or material components.</a:t>
+            </a:r>
+          </a:p>
+        </p:txBody>
+      </p:sp>
+    </p:spTree>
+  </p:cSld>
+  <p:clrMapOvr>
+    <a:masterClrMapping/>
+  </p:clrMapOvr>
+</p:sld>
+</file>
+
 <file path=ppt/theme/theme1.xml><?xml version="1.0" encoding="utf-8"?>
 <a:theme xmlns:a="http://schemas.openxmlformats.org/drawingml/2006/main" name="Office Theme">
   <a:themeElements>

</xml_diff>